<commit_message>
W01 D4 companion simulator, day sheet, TA lab note, board work, Friday pre-read, tiered extras and provenance; morning deck rebuilt after a note correction
Co-Authored-By: Claude Opus 5.5 <noreply@anthropic.com>
Claude-Session: https://claude.ai/code/session_01KVVrwgNCc4sG8fTmEoH6eV
</commit_message>
<xml_diff>
--- a/content/W01/D4/slides/C2_W01_D04_half1_STUDENT.pptx
+++ b/content/W01/D4/slides/C2_W01_D04_half1_STUDENT.pptx
@@ -2005,7 +2005,12 @@
           </a:p>
           <a:p>
             <a:r>
-              <a:t>off the chart. It is "significant" and still worthless. Size is a separate measurement.</a:t>
+              <a:t>off the chart. Five rupees on an order of about Rs 2,200 is a quarter of one percent: "significant",</a:t>
+            </a:r>
+          </a:p>
+          <a:p>
+            <a:r>
+              <a:t>and whether it is worth anything depends on what acting costs. Size is a separate measurement.</a:t>
             </a:r>
           </a:p>
         </p:txBody>

</xml_diff>

<commit_message>
W01 D4: room runs Retail-Plus before any slide shows its p-value; S24 bars in proportion
Round 1 now has the room run the Retail-Plus shuffle at S13 and stages the
p-value trap at S14 to S16 on the share the room has just computed. S21
names the share as the room's own. S24 draws the three consumer segments on
their own axis so Student's bar stands at a tenth of Retail-Plus's, with
Business stated beside the chart. The day sheet and the study notes follow
the new slide numbers. Deck rebuilt.

Co-Authored-By: Claude Opus 5.5 <noreply@anthropic.com>
Claude-Session: https://claude.ai/code/session_01RivitgfrrCcNfHk5BojXmy
</commit_message>
<xml_diff>
--- a/content/W01/D4/slides/C2_W01_D04_half1_STUDENT.pptx
+++ b/content/W01/D4/slides/C2_W01_D04_half1_STUDENT.pptx
@@ -1130,17 +1130,22 @@
           <a:lstStyle/>
           <a:p>
             <a:r>
-              <a:t>LIVE, 3 minutes. Put the sentence up and ask who would have written it. Most hands go up; it is the</a:t>
-            </a:r>
-          </a:p>
-          <a:p>
-            <a:r>
-              <a:t>most common p-value sentence in industry and it appears in the row's list of what the room must</a:t>
-            </a:r>
-          </a:p>
-          <a:p>
-            <a:r>
-              <a:t>handle. Do not correct it yet; the next slide does.</a:t>
+              <a:t>LIVE, 8 minutes. The room runs level 4 of notebook 1 and writes a first-draft sentence without help.</a:t>
+            </a:r>
+          </a:p>
+          <a:p>
+            <a:r>
+              <a:t>Do not read a number out first; every laptop gets the same share because of the seed. When most</a:t>
+            </a:r>
+          </a:p>
+          <a:p>
+            <a:r>
+              <a:t>laptops show a share, ask one pair to read theirs aloud and write it on the board. That number is</a:t>
+            </a:r>
+          </a:p>
+          <a:p>
+            <a:r>
+              <a:t>the one the next three slides work on, and it belongs to the room.</a:t>
             </a:r>
           </a:p>
         </p:txBody>
@@ -1210,17 +1215,17 @@
           <a:lstStyle/>
           <a:p>
             <a:r>
-              <a:t>LIVE, 3 minutes. The chance that a finding is wrong depends on things the shuffle never saw: how</a:t>
-            </a:r>
-          </a:p>
-          <a:p>
-            <a:r>
-              <a:t>plausible a drop was before the data, what else changed, how many segments were tested. Name that</a:t>
-            </a:r>
-          </a:p>
-          <a:p>
-            <a:r>
-              <a:t>in one line and stop; it is a later week's topic.</a:t>
+              <a:t>LIVE, 3 minutes. Put the sentence up next to the room's share on the board and ask whose first</a:t>
+            </a:r>
+          </a:p>
+          <a:p>
+            <a:r>
+              <a:t>draft looks like it. Most hands go up; it is the most common p-value sentence in industry and it</a:t>
+            </a:r>
+          </a:p>
+          <a:p>
+            <a:r>
+              <a:t>appears in the row's list of what the room must handle. Do not correct it yet; the next slide does.</a:t>
             </a:r>
           </a:p>
         </p:txBody>
@@ -1290,12 +1295,17 @@
           <a:lstStyle/>
           <a:p>
             <a:r>
-              <a:t>LIVE, 2 minutes. The rewritten column is what Kavya signs. The third row hands over to round two:</a:t>
-            </a:r>
-          </a:p>
-          <a:p>
-            <a:r>
-              <a:t>real is one call, worth acting on is another.</a:t>
+              <a:t>LIVE, 3 minutes. The chance that a finding is wrong depends on things the shuffle never saw: how</a:t>
+            </a:r>
+          </a:p>
+          <a:p>
+            <a:r>
+              <a:t>plausible a drop was before the data, what else changed, how many segments were tested. Name that</a:t>
+            </a:r>
+          </a:p>
+          <a:p>
+            <a:r>
+              <a:t>in one line and stop; it is a later week's topic.</a:t>
             </a:r>
           </a:p>
         </p:txBody>
@@ -1365,22 +1375,22 @@
           <a:lstStyle/>
           <a:p>
             <a:r>
-              <a:t>LIVE, 10 minutes. The room runs level 4 of notebook 1 and writes the sentence. Do not read a</a:t>
-            </a:r>
-          </a:p>
-          <a:p>
-            <a:r>
-              <a:t>number out first; every laptop gets the same share because of the seed. Collect three sentences</a:t>
-            </a:r>
-          </a:p>
-          <a:p>
-            <a:r>
-              <a:t>aloud and have the room vote each one defensible or wrong. The share they find is the round's</a:t>
-            </a:r>
-          </a:p>
-          <a:p>
-            <a:r>
-              <a:t>answer and belongs to them.</a:t>
+              <a:t>LIVE, 4 minutes. Each pair rewrites its first draft in the rewritten form and reads it to the</a:t>
+            </a:r>
+          </a:p>
+          <a:p>
+            <a:r>
+              <a:t>partner. Collect three sentences aloud and have the room vote each one defensible or wrong. The</a:t>
+            </a:r>
+          </a:p>
+          <a:p>
+            <a:r>
+              <a:t>rewritten column is what Kavya signs. The third row hands over to round two: real is one call,</a:t>
+            </a:r>
+          </a:p>
+          <a:p>
+            <a:r>
+              <a:t>worth acting on is another.</a:t>
             </a:r>
           </a:p>
         </p:txBody>
@@ -2160,12 +2170,17 @@
           <a:lstStyle/>
           <a:p>
             <a:r>
-              <a:t>LIVE, 3 minutes. Delivered revenue in Q2 was Rs 1,28,64,680, of which Business delivered</a:t>
-            </a:r>
-          </a:p>
-          <a:p>
-            <a:r>
-              <a:t>Rs 1,27,64,460. The room computed these on Tuesday and Wednesday. Do not state the Retail-Plus gap</a:t>
+              <a:t>LIVE, 3 minutes. The chart draws the consumer segments alone so their bars stand in proportion; a</a:t>
+            </a:r>
+          </a:p>
+          <a:p>
+            <a:r>
+              <a:t>single axis with Business on it would flatten all three to the floor. Delivered revenue in Q2 was</a:t>
+            </a:r>
+          </a:p>
+          <a:p>
+            <a:r>
+              <a:t>Rs 1,28,64,680, of which Business delivered Rs 1,27,64,460. The room computed these on Tuesday and Wednesday. Do not state the Retail-Plus gap</a:t>
             </a:r>
           </a:p>
           <a:p>
@@ -3880,12 +3895,12 @@
           </a:p>
           <a:p>
             <a:r>
-              <a:t>in code and the Retail-Core demonstration (13), the trap (8), the room's Retail-Plus run (10), and</a:t>
-            </a:r>
-          </a:p>
-          <a:p>
-            <a:r>
-              <a:t>Kavya's review (2). Notebook 1 runs beside it.</a:t>
+              <a:t>in code and the Retail-Core demonstration (13), the room's Retail-Plus run (8), the trap staged on</a:t>
+            </a:r>
+          </a:p>
+          <a:p>
+            <a:r>
+              <a:t>the room's own share and its fix (10), and Kavya's review (2). Notebook 1 runs beside it.</a:t>
             </a:r>
           </a:p>
         </p:txBody>
@@ -13274,7 +13289,7 @@
                 </a:solidFill>
                 <a:latin typeface="Georgia"/>
               </a:rPr>
-              <a:t>The plausible wrong answer</a:t>
+              <a:t>Your turn: Retail-Plus, 5,000 shuffles</a:t>
             </a:r>
           </a:p>
         </p:txBody>
@@ -13309,45 +13324,144 @@
                 </a:solidFill>
                 <a:latin typeface="Calibri"/>
               </a:rPr>
-              <a:t>A draft note, written in a hurry after a shuffle test came back at 0.03.</a:t>
-            </a:r>
-          </a:p>
-        </p:txBody>
-      </p:sp>
-      <p:pic>
-        <p:nvPicPr>
-          <p:cNvPr id="9" name="mermaid diagram" descr="e3c7a847657e72e7.png"/>
-          <p:cNvPicPr>
-            <a:picLocks noChangeAspect="1"/>
-          </p:cNvPicPr>
-          <p:nvPr/>
-        </p:nvPicPr>
-        <p:blipFill>
-          <a:blip r:embed="rId6"/>
-          <a:stretch>
-            <a:fillRect/>
-          </a:stretch>
-        </p:blipFill>
-        <p:spPr>
-          <a:xfrm>
-            <a:off x="2166785" y="1956816"/>
-            <a:ext cx="7858125" cy="1128712"/>
-          </a:xfrm>
-          <a:prstGeom prst="rect">
-            <a:avLst/>
-          </a:prstGeom>
-        </p:spPr>
-      </p:pic>
-      <p:sp>
-        <p:nvSpPr>
-          <p:cNvPr id="10" name="Rounded Rectangle 9"/>
+              <a:t>The same loop on the segment Meera asked about, run by the room before anyone says a number.</a:t>
+            </a:r>
+          </a:p>
+        </p:txBody>
+      </p:sp>
+      <p:sp>
+        <p:nvSpPr>
+          <p:cNvPr id="9" name="Rectangle 8"/>
           <p:cNvSpPr/>
           <p:nvPr/>
         </p:nvSpPr>
         <p:spPr>
           <a:xfrm>
-            <a:off x="530352" y="3231832"/>
-            <a:ext cx="11130991" cy="1121664"/>
+            <a:off x="1853145" y="2523744"/>
+            <a:ext cx="8485403" cy="18288"/>
+          </a:xfrm>
+          <a:prstGeom prst="rect">
+            <a:avLst/>
+          </a:prstGeom>
+          <a:solidFill>
+            <a:srgbClr val="CFC9EE"/>
+          </a:solidFill>
+          <a:ln>
+            <a:noFill/>
+          </a:ln>
+          <a:effectLst/>
+        </p:spPr>
+        <p:style>
+          <a:lnRef idx="1">
+            <a:schemeClr val="accent1"/>
+          </a:lnRef>
+          <a:fillRef idx="3">
+            <a:schemeClr val="accent1"/>
+          </a:fillRef>
+          <a:effectRef idx="2">
+            <a:schemeClr val="accent1"/>
+          </a:effectRef>
+          <a:fontRef idx="minor">
+            <a:schemeClr val="lt1"/>
+          </a:fontRef>
+        </p:style>
+        <p:txBody>
+          <a:bodyPr rtlCol="0" anchor="ctr" wrap="square"/>
+          <a:lstStyle/>
+          <a:p>
+            <a:pPr algn="ctr"/>
+          </a:p>
+        </p:txBody>
+      </p:sp>
+      <p:sp>
+        <p:nvSpPr>
+          <p:cNvPr id="10" name="TextBox 9"/>
+          <p:cNvSpPr txBox="1"/>
+          <p:nvPr/>
+        </p:nvSpPr>
+        <p:spPr>
+          <a:xfrm>
+            <a:off x="530352" y="1956816"/>
+            <a:ext cx="2645587" cy="168656"/>
+          </a:xfrm>
+          <a:prstGeom prst="rect">
+            <a:avLst/>
+          </a:prstGeom>
+          <a:noFill/>
+        </p:spPr>
+        <p:txBody>
+          <a:bodyPr wrap="square" anchor="t" lIns="0" rIns="0" tIns="0" bIns="0">
+            <a:spAutoFit/>
+          </a:bodyPr>
+          <a:lstStyle/>
+          <a:p>
+            <a:pPr algn="ctr"/>
+            <a:r>
+              <a:rPr sz="800" b="1" i="0" spc="250">
+                <a:solidFill>
+                  <a:srgbClr val="5B3FD6"/>
+                </a:solidFill>
+                <a:latin typeface="Calibri"/>
+              </a:rPr>
+              <a:t>STEP 1</a:t>
+            </a:r>
+          </a:p>
+        </p:txBody>
+      </p:sp>
+      <p:sp>
+        <p:nvSpPr>
+          <p:cNvPr id="11" name="Oval 10"/>
+          <p:cNvSpPr/>
+          <p:nvPr/>
+        </p:nvSpPr>
+        <p:spPr>
+          <a:xfrm>
+            <a:off x="1752561" y="2432304"/>
+            <a:ext cx="201168" cy="201168"/>
+          </a:xfrm>
+          <a:prstGeom prst="ellipse">
+            <a:avLst/>
+          </a:prstGeom>
+          <a:solidFill>
+            <a:srgbClr val="5B3FD6"/>
+          </a:solidFill>
+          <a:ln>
+            <a:noFill/>
+          </a:ln>
+          <a:effectLst/>
+        </p:spPr>
+        <p:style>
+          <a:lnRef idx="1">
+            <a:schemeClr val="accent1"/>
+          </a:lnRef>
+          <a:fillRef idx="3">
+            <a:schemeClr val="accent1"/>
+          </a:fillRef>
+          <a:effectRef idx="2">
+            <a:schemeClr val="accent1"/>
+          </a:effectRef>
+          <a:fontRef idx="minor">
+            <a:schemeClr val="lt1"/>
+          </a:fontRef>
+        </p:style>
+        <p:txBody>
+          <a:bodyPr rtlCol="0" anchor="ctr" wrap="square"/>
+          <a:lstStyle/>
+          <a:p>
+            <a:pPr algn="ctr"/>
+          </a:p>
+        </p:txBody>
+      </p:sp>
+      <p:sp>
+        <p:nvSpPr>
+          <p:cNvPr id="12" name="Rounded Rectangle 11"/>
+          <p:cNvSpPr/>
+          <p:nvPr/>
+        </p:nvSpPr>
+        <p:spPr>
+          <a:xfrm>
+            <a:off x="530352" y="2843784"/>
+            <a:ext cx="2645587" cy="1249680"/>
           </a:xfrm>
           <a:prstGeom prst="roundRect">
             <a:avLst>
@@ -13355,7 +13469,7 @@
             </a:avLst>
           </a:prstGeom>
           <a:solidFill>
-            <a:srgbClr val="F7F5FD"/>
+            <a:srgbClr val="FFFFFF"/>
           </a:solidFill>
           <a:ln w="9525">
             <a:solidFill>
@@ -13394,14 +13508,119 @@
       </p:sp>
       <p:sp>
         <p:nvSpPr>
-          <p:cNvPr id="11" name="Oval 10"/>
+          <p:cNvPr id="13" name="TextBox 12"/>
+          <p:cNvSpPr txBox="1"/>
+          <p:nvPr/>
+        </p:nvSpPr>
+        <p:spPr>
+          <a:xfrm>
+            <a:off x="694944" y="2990088"/>
+            <a:ext cx="2316403" cy="251205"/>
+          </a:xfrm>
+          <a:prstGeom prst="rect">
+            <a:avLst/>
+          </a:prstGeom>
+          <a:noFill/>
+        </p:spPr>
+        <p:txBody>
+          <a:bodyPr wrap="square" anchor="t" lIns="0" rIns="0" tIns="0" bIns="0">
+            <a:spAutoFit/>
+          </a:bodyPr>
+          <a:lstStyle/>
+          <a:p>
+            <a:pPr algn="l"/>
+            <a:r>
+              <a:rPr sz="1300" b="1" i="0">
+                <a:solidFill>
+                  <a:srgbClr val="1A0F5C"/>
+                </a:solidFill>
+                <a:latin typeface="Calibri"/>
+              </a:rPr>
+              <a:t>The measure</a:t>
+            </a:r>
+          </a:p>
+        </p:txBody>
+      </p:sp>
+      <p:sp>
+        <p:nvSpPr>
+          <p:cNvPr id="14" name="TextBox 13"/>
+          <p:cNvSpPr txBox="1"/>
+          <p:nvPr/>
+        </p:nvSpPr>
+        <p:spPr>
+          <a:xfrm>
+            <a:off x="694944" y="3277870"/>
+            <a:ext cx="2316403" cy="531876"/>
+          </a:xfrm>
+          <a:prstGeom prst="rect">
+            <a:avLst/>
+          </a:prstGeom>
+          <a:noFill/>
+        </p:spPr>
+        <p:txBody>
+          <a:bodyPr wrap="square" anchor="t" lIns="0" rIns="0" tIns="0" bIns="0">
+            <a:spAutoFit/>
+          </a:bodyPr>
+          <a:lstStyle/>
+          <a:p>
+            <a:pPr algn="l"/>
+            <a:r>
+              <a:rPr sz="1000" b="0" i="0">
+                <a:solidFill>
+                  <a:srgbClr val="6B6690"/>
+                </a:solidFill>
+                <a:latin typeface="Calibri"/>
+              </a:rPr>
+              <a:t>Delivered revenue per Retail-Plus member, Q1 and Q2, from notebook 1, level 4.</a:t>
+            </a:r>
+          </a:p>
+        </p:txBody>
+      </p:sp>
+      <p:sp>
+        <p:nvSpPr>
+          <p:cNvPr id="15" name="TextBox 14"/>
+          <p:cNvSpPr txBox="1"/>
+          <p:nvPr/>
+        </p:nvSpPr>
+        <p:spPr>
+          <a:xfrm>
+            <a:off x="3358819" y="1956816"/>
+            <a:ext cx="2645587" cy="168656"/>
+          </a:xfrm>
+          <a:prstGeom prst="rect">
+            <a:avLst/>
+          </a:prstGeom>
+          <a:noFill/>
+        </p:spPr>
+        <p:txBody>
+          <a:bodyPr wrap="square" anchor="t" lIns="0" rIns="0" tIns="0" bIns="0">
+            <a:spAutoFit/>
+          </a:bodyPr>
+          <a:lstStyle/>
+          <a:p>
+            <a:pPr algn="ctr"/>
+            <a:r>
+              <a:rPr sz="800" b="1" i="0" spc="250">
+                <a:solidFill>
+                  <a:srgbClr val="5B3FD6"/>
+                </a:solidFill>
+                <a:latin typeface="Calibri"/>
+              </a:rPr>
+              <a:t>STEP 2</a:t>
+            </a:r>
+          </a:p>
+        </p:txBody>
+      </p:sp>
+      <p:sp>
+        <p:nvSpPr>
+          <p:cNvPr id="16" name="Oval 15"/>
           <p:cNvSpPr/>
           <p:nvPr/>
         </p:nvSpPr>
         <p:spPr>
           <a:xfrm>
-            <a:off x="758952" y="3564064"/>
-            <a:ext cx="457200" cy="457200"/>
+            <a:off x="4581029" y="2432304"/>
+            <a:ext cx="201168" cy="201168"/>
           </a:xfrm>
           <a:prstGeom prst="ellipse">
             <a:avLst/>
@@ -13436,40 +13655,70 @@
           </a:p>
         </p:txBody>
       </p:sp>
-      <p:pic>
-        <p:nvPicPr>
-          <p:cNvPr id="12" name="Picture 11" descr="bug_39ada6eff46d.png"/>
-          <p:cNvPicPr>
-            <a:picLocks noChangeAspect="1"/>
-          </p:cNvPicPr>
-          <p:nvPr/>
-        </p:nvPicPr>
-        <p:blipFill>
-          <a:blip r:embed="rId5"/>
-          <a:stretch>
-            <a:fillRect/>
-          </a:stretch>
-        </p:blipFill>
-        <p:spPr>
-          <a:xfrm>
-            <a:off x="868680" y="3673792"/>
-            <a:ext cx="237744" cy="237744"/>
-          </a:xfrm>
-          <a:prstGeom prst="rect">
-            <a:avLst/>
-          </a:prstGeom>
-        </p:spPr>
-      </p:pic>
-      <p:sp>
-        <p:nvSpPr>
-          <p:cNvPr id="13" name="TextBox 12"/>
-          <p:cNvSpPr txBox="1"/>
-          <p:nvPr/>
-        </p:nvSpPr>
-        <p:spPr>
-          <a:xfrm>
-            <a:off x="1399031" y="3378136"/>
-            <a:ext cx="9987991" cy="160401"/>
+      <p:sp>
+        <p:nvSpPr>
+          <p:cNvPr id="17" name="Rounded Rectangle 16"/>
+          <p:cNvSpPr/>
+          <p:nvPr/>
+        </p:nvSpPr>
+        <p:spPr>
+          <a:xfrm>
+            <a:off x="3358819" y="2843784"/>
+            <a:ext cx="2645587" cy="1249680"/>
+          </a:xfrm>
+          <a:prstGeom prst="roundRect">
+            <a:avLst>
+              <a:gd name="adj" fmla="val 5000"/>
+            </a:avLst>
+          </a:prstGeom>
+          <a:solidFill>
+            <a:srgbClr val="FFFFFF"/>
+          </a:solidFill>
+          <a:ln w="9525">
+            <a:solidFill>
+              <a:srgbClr val="E4E1F1"/>
+            </a:solidFill>
+          </a:ln>
+          <a:effectLst>
+            <a:outerShdw blurRad="76200" dist="19050" dir="5400000" algn="bl" rotWithShape="0">
+              <a:srgbClr val="1A0F5C">
+                <a:alpha val="12000"/>
+              </a:srgbClr>
+            </a:outerShdw>
+          </a:effectLst>
+        </p:spPr>
+        <p:style>
+          <a:lnRef idx="1">
+            <a:schemeClr val="accent1"/>
+          </a:lnRef>
+          <a:fillRef idx="3">
+            <a:schemeClr val="accent1"/>
+          </a:fillRef>
+          <a:effectRef idx="2">
+            <a:schemeClr val="accent1"/>
+          </a:effectRef>
+          <a:fontRef idx="minor">
+            <a:schemeClr val="lt1"/>
+          </a:fontRef>
+        </p:style>
+        <p:txBody>
+          <a:bodyPr rtlCol="0" anchor="ctr" wrap="square"/>
+          <a:lstStyle/>
+          <a:p>
+            <a:pPr algn="ctr"/>
+          </a:p>
+        </p:txBody>
+      </p:sp>
+      <p:sp>
+        <p:nvSpPr>
+          <p:cNvPr id="18" name="TextBox 17"/>
+          <p:cNvSpPr txBox="1"/>
+          <p:nvPr/>
+        </p:nvSpPr>
+        <p:spPr>
+          <a:xfrm>
+            <a:off x="3523411" y="2990088"/>
+            <a:ext cx="2316403" cy="251205"/>
           </a:xfrm>
           <a:prstGeom prst="rect">
             <a:avLst/>
@@ -13484,54 +13733,467 @@
           <a:p>
             <a:pPr algn="l"/>
             <a:r>
-              <a:rPr sz="750" b="1" i="0" spc="250">
+              <a:rPr sz="1300" b="1" i="0">
+                <a:solidFill>
+                  <a:srgbClr val="1A0F5C"/>
+                </a:solidFill>
+                <a:latin typeface="Calibri"/>
+              </a:rPr>
+              <a:t>The real gap</a:t>
+            </a:r>
+          </a:p>
+        </p:txBody>
+      </p:sp>
+      <p:sp>
+        <p:nvSpPr>
+          <p:cNvPr id="19" name="TextBox 18"/>
+          <p:cNvSpPr txBox="1"/>
+          <p:nvPr/>
+        </p:nvSpPr>
+        <p:spPr>
+          <a:xfrm>
+            <a:off x="3523411" y="3277870"/>
+            <a:ext cx="2316403" cy="366776"/>
+          </a:xfrm>
+          <a:prstGeom prst="rect">
+            <a:avLst/>
+          </a:prstGeom>
+          <a:noFill/>
+        </p:spPr>
+        <p:txBody>
+          <a:bodyPr wrap="square" anchor="t" lIns="0" rIns="0" tIns="0" bIns="0">
+            <a:spAutoFit/>
+          </a:bodyPr>
+          <a:lstStyle/>
+          <a:p>
+            <a:pPr algn="l"/>
+            <a:r>
+              <a:rPr sz="1000" b="0" i="0">
+                <a:solidFill>
+                  <a:srgbClr val="6B6690"/>
+                </a:solidFill>
+                <a:latin typeface="Calibri"/>
+              </a:rPr>
+              <a:t>Q1 mean less Q2 mean, printed in rupees before any shuffle runs.</a:t>
+            </a:r>
+          </a:p>
+        </p:txBody>
+      </p:sp>
+      <p:sp>
+        <p:nvSpPr>
+          <p:cNvPr id="20" name="TextBox 19"/>
+          <p:cNvSpPr txBox="1"/>
+          <p:nvPr/>
+        </p:nvSpPr>
+        <p:spPr>
+          <a:xfrm>
+            <a:off x="6187287" y="1956816"/>
+            <a:ext cx="2645587" cy="168656"/>
+          </a:xfrm>
+          <a:prstGeom prst="rect">
+            <a:avLst/>
+          </a:prstGeom>
+          <a:noFill/>
+        </p:spPr>
+        <p:txBody>
+          <a:bodyPr wrap="square" anchor="t" lIns="0" rIns="0" tIns="0" bIns="0">
+            <a:spAutoFit/>
+          </a:bodyPr>
+          <a:lstStyle/>
+          <a:p>
+            <a:pPr algn="ctr"/>
+            <a:r>
+              <a:rPr sz="800" b="1" i="0" spc="250">
                 <a:solidFill>
                   <a:srgbClr val="5B3FD6"/>
                 </a:solidFill>
                 <a:latin typeface="Calibri"/>
               </a:rPr>
-              <a:t>WHAT BREAKS</a:t>
-            </a:r>
-          </a:p>
-        </p:txBody>
-      </p:sp>
-      <p:sp>
-        <p:nvSpPr>
-          <p:cNvPr id="14" name="TextBox 13"/>
-          <p:cNvSpPr txBox="1"/>
-          <p:nvPr/>
-        </p:nvSpPr>
-        <p:spPr>
-          <a:xfrm>
-            <a:off x="1399031" y="3597592"/>
-            <a:ext cx="9987991" cy="682752"/>
-          </a:xfrm>
-          <a:prstGeom prst="rect">
-            <a:avLst/>
-          </a:prstGeom>
-          <a:noFill/>
-        </p:spPr>
-        <p:txBody>
-          <a:bodyPr wrap="square" anchor="t" lIns="0" rIns="0" tIns="0" bIns="0">
-            <a:spAutoFit/>
-          </a:bodyPr>
-          <a:lstStyle/>
-          <a:p>
-            <a:r>
-              <a:rPr sz="1500" b="0" i="0">
-                <a:solidFill>
-                  <a:srgbClr val="1A1440"/>
-                </a:solidFill>
-                <a:latin typeface="Calibri"/>
-              </a:rPr>
-              <a:t>"p = 0.03, so there is a 3 percent chance we are wrong" reads as precise, sounds like probability, and sends Meera into Monday certain.</a:t>
-            </a:r>
-          </a:p>
-        </p:txBody>
-      </p:sp>
-      <p:sp>
-        <p:nvSpPr>
-          <p:cNvPr id="15" name="Oval 14"/>
+              <a:t>STEP 3</a:t>
+            </a:r>
+          </a:p>
+        </p:txBody>
+      </p:sp>
+      <p:sp>
+        <p:nvSpPr>
+          <p:cNvPr id="21" name="Oval 20"/>
+          <p:cNvSpPr/>
+          <p:nvPr/>
+        </p:nvSpPr>
+        <p:spPr>
+          <a:xfrm>
+            <a:off x="7409497" y="2432304"/>
+            <a:ext cx="201168" cy="201168"/>
+          </a:xfrm>
+          <a:prstGeom prst="ellipse">
+            <a:avLst/>
+          </a:prstGeom>
+          <a:solidFill>
+            <a:srgbClr val="5B3FD6"/>
+          </a:solidFill>
+          <a:ln>
+            <a:noFill/>
+          </a:ln>
+          <a:effectLst/>
+        </p:spPr>
+        <p:style>
+          <a:lnRef idx="1">
+            <a:schemeClr val="accent1"/>
+          </a:lnRef>
+          <a:fillRef idx="3">
+            <a:schemeClr val="accent1"/>
+          </a:fillRef>
+          <a:effectRef idx="2">
+            <a:schemeClr val="accent1"/>
+          </a:effectRef>
+          <a:fontRef idx="minor">
+            <a:schemeClr val="lt1"/>
+          </a:fontRef>
+        </p:style>
+        <p:txBody>
+          <a:bodyPr rtlCol="0" anchor="ctr" wrap="square"/>
+          <a:lstStyle/>
+          <a:p>
+            <a:pPr algn="ctr"/>
+          </a:p>
+        </p:txBody>
+      </p:sp>
+      <p:sp>
+        <p:nvSpPr>
+          <p:cNvPr id="22" name="Rounded Rectangle 21"/>
+          <p:cNvSpPr/>
+          <p:nvPr/>
+        </p:nvSpPr>
+        <p:spPr>
+          <a:xfrm>
+            <a:off x="6187287" y="2843784"/>
+            <a:ext cx="2645587" cy="1249680"/>
+          </a:xfrm>
+          <a:prstGeom prst="roundRect">
+            <a:avLst>
+              <a:gd name="adj" fmla="val 5000"/>
+            </a:avLst>
+          </a:prstGeom>
+          <a:solidFill>
+            <a:srgbClr val="FFFFFF"/>
+          </a:solidFill>
+          <a:ln w="9525">
+            <a:solidFill>
+              <a:srgbClr val="E4E1F1"/>
+            </a:solidFill>
+          </a:ln>
+          <a:effectLst>
+            <a:outerShdw blurRad="76200" dist="19050" dir="5400000" algn="bl" rotWithShape="0">
+              <a:srgbClr val="1A0F5C">
+                <a:alpha val="12000"/>
+              </a:srgbClr>
+            </a:outerShdw>
+          </a:effectLst>
+        </p:spPr>
+        <p:style>
+          <a:lnRef idx="1">
+            <a:schemeClr val="accent1"/>
+          </a:lnRef>
+          <a:fillRef idx="3">
+            <a:schemeClr val="accent1"/>
+          </a:fillRef>
+          <a:effectRef idx="2">
+            <a:schemeClr val="accent1"/>
+          </a:effectRef>
+          <a:fontRef idx="minor">
+            <a:schemeClr val="lt1"/>
+          </a:fontRef>
+        </p:style>
+        <p:txBody>
+          <a:bodyPr rtlCol="0" anchor="ctr" wrap="square"/>
+          <a:lstStyle/>
+          <a:p>
+            <a:pPr algn="ctr"/>
+          </a:p>
+        </p:txBody>
+      </p:sp>
+      <p:sp>
+        <p:nvSpPr>
+          <p:cNvPr id="23" name="TextBox 22"/>
+          <p:cNvSpPr txBox="1"/>
+          <p:nvPr/>
+        </p:nvSpPr>
+        <p:spPr>
+          <a:xfrm>
+            <a:off x="6351879" y="2990088"/>
+            <a:ext cx="2316403" cy="251205"/>
+          </a:xfrm>
+          <a:prstGeom prst="rect">
+            <a:avLst/>
+          </a:prstGeom>
+          <a:noFill/>
+        </p:spPr>
+        <p:txBody>
+          <a:bodyPr wrap="square" anchor="t" lIns="0" rIns="0" tIns="0" bIns="0">
+            <a:spAutoFit/>
+          </a:bodyPr>
+          <a:lstStyle/>
+          <a:p>
+            <a:pPr algn="l"/>
+            <a:r>
+              <a:rPr sz="1300" b="1" i="0">
+                <a:solidFill>
+                  <a:srgbClr val="1A0F5C"/>
+                </a:solidFill>
+                <a:latin typeface="Calibri"/>
+              </a:rPr>
+              <a:t>The shuffles</a:t>
+            </a:r>
+          </a:p>
+        </p:txBody>
+      </p:sp>
+      <p:sp>
+        <p:nvSpPr>
+          <p:cNvPr id="24" name="TextBox 23"/>
+          <p:cNvSpPr txBox="1"/>
+          <p:nvPr/>
+        </p:nvSpPr>
+        <p:spPr>
+          <a:xfrm>
+            <a:off x="6351879" y="3277870"/>
+            <a:ext cx="2316403" cy="366776"/>
+          </a:xfrm>
+          <a:prstGeom prst="rect">
+            <a:avLst/>
+          </a:prstGeom>
+          <a:noFill/>
+        </p:spPr>
+        <p:txBody>
+          <a:bodyPr wrap="square" anchor="t" lIns="0" rIns="0" tIns="0" bIns="0">
+            <a:spAutoFit/>
+          </a:bodyPr>
+          <a:lstStyle/>
+          <a:p>
+            <a:pPr algn="l"/>
+            <a:r>
+              <a:rPr sz="1000" b="0" i="0">
+                <a:solidFill>
+                  <a:srgbClr val="6B6690"/>
+                </a:solidFill>
+                <a:latin typeface="Calibri"/>
+              </a:rPr>
+              <a:t>5,000, seed 2026, and the share at least as large as the real gap.</a:t>
+            </a:r>
+          </a:p>
+        </p:txBody>
+      </p:sp>
+      <p:sp>
+        <p:nvSpPr>
+          <p:cNvPr id="25" name="TextBox 24"/>
+          <p:cNvSpPr txBox="1"/>
+          <p:nvPr/>
+        </p:nvSpPr>
+        <p:spPr>
+          <a:xfrm>
+            <a:off x="9015755" y="1956816"/>
+            <a:ext cx="2645587" cy="168656"/>
+          </a:xfrm>
+          <a:prstGeom prst="rect">
+            <a:avLst/>
+          </a:prstGeom>
+          <a:noFill/>
+        </p:spPr>
+        <p:txBody>
+          <a:bodyPr wrap="square" anchor="t" lIns="0" rIns="0" tIns="0" bIns="0">
+            <a:spAutoFit/>
+          </a:bodyPr>
+          <a:lstStyle/>
+          <a:p>
+            <a:pPr algn="ctr"/>
+            <a:r>
+              <a:rPr sz="800" b="1" i="0" spc="250">
+                <a:solidFill>
+                  <a:srgbClr val="5B3FD6"/>
+                </a:solidFill>
+                <a:latin typeface="Calibri"/>
+              </a:rPr>
+              <a:t>STEP 4</a:t>
+            </a:r>
+          </a:p>
+        </p:txBody>
+      </p:sp>
+      <p:sp>
+        <p:nvSpPr>
+          <p:cNvPr id="26" name="Oval 25"/>
+          <p:cNvSpPr/>
+          <p:nvPr/>
+        </p:nvSpPr>
+        <p:spPr>
+          <a:xfrm>
+            <a:off x="10237965" y="2432304"/>
+            <a:ext cx="201168" cy="201168"/>
+          </a:xfrm>
+          <a:prstGeom prst="ellipse">
+            <a:avLst/>
+          </a:prstGeom>
+          <a:solidFill>
+            <a:srgbClr val="D9A7FF"/>
+          </a:solidFill>
+          <a:ln>
+            <a:noFill/>
+          </a:ln>
+          <a:effectLst/>
+        </p:spPr>
+        <p:style>
+          <a:lnRef idx="1">
+            <a:schemeClr val="accent1"/>
+          </a:lnRef>
+          <a:fillRef idx="3">
+            <a:schemeClr val="accent1"/>
+          </a:fillRef>
+          <a:effectRef idx="2">
+            <a:schemeClr val="accent1"/>
+          </a:effectRef>
+          <a:fontRef idx="minor">
+            <a:schemeClr val="lt1"/>
+          </a:fontRef>
+        </p:style>
+        <p:txBody>
+          <a:bodyPr rtlCol="0" anchor="ctr" wrap="square"/>
+          <a:lstStyle/>
+          <a:p>
+            <a:pPr algn="ctr"/>
+          </a:p>
+        </p:txBody>
+      </p:sp>
+      <p:sp>
+        <p:nvSpPr>
+          <p:cNvPr id="27" name="Rounded Rectangle 26"/>
+          <p:cNvSpPr/>
+          <p:nvPr/>
+        </p:nvSpPr>
+        <p:spPr>
+          <a:xfrm>
+            <a:off x="9015755" y="2843784"/>
+            <a:ext cx="2645587" cy="1249680"/>
+          </a:xfrm>
+          <a:prstGeom prst="roundRect">
+            <a:avLst>
+              <a:gd name="adj" fmla="val 5000"/>
+            </a:avLst>
+          </a:prstGeom>
+          <a:gradFill rotWithShape="1">
+            <a:gsLst>
+              <a:gs pos="0">
+                <a:srgbClr val="2C1A86"/>
+              </a:gs>
+              <a:gs pos="100000">
+                <a:srgbClr val="1A0F5C"/>
+              </a:gs>
+            </a:gsLst>
+            <a:lin scaled="0" ang="16200000"/>
+          </a:gradFill>
+          <a:ln>
+            <a:noFill/>
+          </a:ln>
+          <a:effectLst>
+            <a:outerShdw blurRad="76200" dist="19050" dir="5400000" algn="bl" rotWithShape="0">
+              <a:srgbClr val="1A0F5C">
+                <a:alpha val="12000"/>
+              </a:srgbClr>
+            </a:outerShdw>
+          </a:effectLst>
+        </p:spPr>
+        <p:style>
+          <a:lnRef idx="1">
+            <a:schemeClr val="accent1"/>
+          </a:lnRef>
+          <a:fillRef idx="3">
+            <a:schemeClr val="accent1"/>
+          </a:fillRef>
+          <a:effectRef idx="2">
+            <a:schemeClr val="accent1"/>
+          </a:effectRef>
+          <a:fontRef idx="minor">
+            <a:schemeClr val="lt1"/>
+          </a:fontRef>
+        </p:style>
+        <p:txBody>
+          <a:bodyPr rtlCol="0" anchor="ctr" wrap="square"/>
+          <a:lstStyle/>
+          <a:p>
+            <a:pPr algn="ctr"/>
+          </a:p>
+        </p:txBody>
+      </p:sp>
+      <p:sp>
+        <p:nvSpPr>
+          <p:cNvPr id="28" name="TextBox 27"/>
+          <p:cNvSpPr txBox="1"/>
+          <p:nvPr/>
+        </p:nvSpPr>
+        <p:spPr>
+          <a:xfrm>
+            <a:off x="9180347" y="2990088"/>
+            <a:ext cx="2316403" cy="251205"/>
+          </a:xfrm>
+          <a:prstGeom prst="rect">
+            <a:avLst/>
+          </a:prstGeom>
+          <a:noFill/>
+        </p:spPr>
+        <p:txBody>
+          <a:bodyPr wrap="square" anchor="t" lIns="0" rIns="0" tIns="0" bIns="0">
+            <a:spAutoFit/>
+          </a:bodyPr>
+          <a:lstStyle/>
+          <a:p>
+            <a:pPr algn="l"/>
+            <a:r>
+              <a:rPr sz="1300" b="1" i="0">
+                <a:solidFill>
+                  <a:srgbClr val="FFFFFF"/>
+                </a:solidFill>
+                <a:latin typeface="Calibri"/>
+              </a:rPr>
+              <a:t>The first draft</a:t>
+            </a:r>
+          </a:p>
+        </p:txBody>
+      </p:sp>
+      <p:sp>
+        <p:nvSpPr>
+          <p:cNvPr id="29" name="TextBox 28"/>
+          <p:cNvSpPr txBox="1"/>
+          <p:nvPr/>
+        </p:nvSpPr>
+        <p:spPr>
+          <a:xfrm>
+            <a:off x="9180347" y="3277870"/>
+            <a:ext cx="2316403" cy="366776"/>
+          </a:xfrm>
+          <a:prstGeom prst="rect">
+            <a:avLst/>
+          </a:prstGeom>
+          <a:noFill/>
+        </p:spPr>
+        <p:txBody>
+          <a:bodyPr wrap="square" anchor="t" lIns="0" rIns="0" tIns="0" bIns="0">
+            <a:spAutoFit/>
+          </a:bodyPr>
+          <a:lstStyle/>
+          <a:p>
+            <a:pPr algn="l"/>
+            <a:r>
+              <a:rPr sz="1000" b="0" i="0">
+                <a:solidFill>
+                  <a:srgbClr val="CFC9EE"/>
+                </a:solidFill>
+                <a:latin typeface="Calibri"/>
+              </a:rPr>
+              <a:t>One line to Meera on what your share means, written fast and kept.</a:t>
+            </a:r>
+          </a:p>
+        </p:txBody>
+      </p:sp>
+      <p:sp>
+        <p:nvSpPr>
+          <p:cNvPr id="30" name="Oval 29"/>
           <p:cNvSpPr/>
           <p:nvPr/>
         </p:nvSpPr>
@@ -13575,7 +14237,7 @@
       </p:sp>
       <p:sp>
         <p:nvSpPr>
-          <p:cNvPr id="16" name="TextBox 15"/>
+          <p:cNvPr id="31" name="TextBox 30"/>
           <p:cNvSpPr txBox="1"/>
           <p:nvPr/>
         </p:nvSpPr>
@@ -13610,7 +14272,7 @@
       </p:sp>
       <p:sp>
         <p:nvSpPr>
-          <p:cNvPr id="17" name="Oval 16"/>
+          <p:cNvPr id="32" name="Oval 31"/>
           <p:cNvSpPr/>
           <p:nvPr/>
         </p:nvSpPr>
@@ -13654,7 +14316,7 @@
       </p:sp>
       <p:sp>
         <p:nvSpPr>
-          <p:cNvPr id="18" name="TextBox 17"/>
+          <p:cNvPr id="33" name="TextBox 32"/>
           <p:cNvSpPr txBox="1"/>
           <p:nvPr/>
         </p:nvSpPr>
@@ -13689,7 +14351,7 @@
       </p:sp>
       <p:sp>
         <p:nvSpPr>
-          <p:cNvPr id="19" name="Oval 18"/>
+          <p:cNvPr id="34" name="Oval 33"/>
           <p:cNvSpPr/>
           <p:nvPr/>
         </p:nvSpPr>
@@ -13733,7 +14395,7 @@
       </p:sp>
       <p:sp>
         <p:nvSpPr>
-          <p:cNvPr id="20" name="TextBox 19"/>
+          <p:cNvPr id="35" name="TextBox 34"/>
           <p:cNvSpPr txBox="1"/>
           <p:nvPr/>
         </p:nvSpPr>
@@ -13768,7 +14430,7 @@
       </p:sp>
       <p:sp>
         <p:nvSpPr>
-          <p:cNvPr id="21" name="Oval 20"/>
+          <p:cNvPr id="36" name="Oval 35"/>
           <p:cNvSpPr/>
           <p:nvPr/>
         </p:nvSpPr>
@@ -13812,7 +14474,7 @@
       </p:sp>
       <p:sp>
         <p:nvSpPr>
-          <p:cNvPr id="22" name="TextBox 21"/>
+          <p:cNvPr id="37" name="TextBox 36"/>
           <p:cNvSpPr txBox="1"/>
           <p:nvPr/>
         </p:nvSpPr>
@@ -13847,7 +14509,7 @@
       </p:sp>
       <p:sp>
         <p:nvSpPr>
-          <p:cNvPr id="23" name="TextBox 22"/>
+          <p:cNvPr id="38" name="TextBox 37"/>
           <p:cNvSpPr txBox="1"/>
           <p:nvPr/>
         </p:nvSpPr>
@@ -14081,6 +14743,813 @@
                 </a:solidFill>
                 <a:latin typeface="Georgia"/>
               </a:rPr>
+              <a:t>The plausible wrong answer</a:t>
+            </a:r>
+          </a:p>
+        </p:txBody>
+      </p:sp>
+      <p:sp>
+        <p:nvSpPr>
+          <p:cNvPr id="8" name="TextBox 7"/>
+          <p:cNvSpPr txBox="1"/>
+          <p:nvPr/>
+        </p:nvSpPr>
+        <p:spPr>
+          <a:xfrm>
+            <a:off x="530352" y="1243584"/>
+            <a:ext cx="11130991" cy="234696"/>
+          </a:xfrm>
+          <a:prstGeom prst="rect">
+            <a:avLst/>
+          </a:prstGeom>
+          <a:noFill/>
+        </p:spPr>
+        <p:txBody>
+          <a:bodyPr wrap="square" anchor="t" lIns="0" rIns="0" tIns="0" bIns="0">
+            <a:spAutoFit/>
+          </a:bodyPr>
+          <a:lstStyle/>
+          <a:p>
+            <a:pPr algn="l"/>
+            <a:r>
+              <a:rPr sz="1200" b="0" i="0">
+                <a:solidFill>
+                  <a:srgbClr val="6B6690"/>
+                </a:solidFill>
+                <a:latin typeface="Calibri"/>
+              </a:rPr>
+              <a:t>A draft note, written in a hurry from the share the room has just computed.</a:t>
+            </a:r>
+          </a:p>
+        </p:txBody>
+      </p:sp>
+      <p:pic>
+        <p:nvPicPr>
+          <p:cNvPr id="9" name="mermaid diagram" descr="110e5667504f6893.png"/>
+          <p:cNvPicPr>
+            <a:picLocks noChangeAspect="1"/>
+          </p:cNvPicPr>
+          <p:nvPr/>
+        </p:nvPicPr>
+        <p:blipFill>
+          <a:blip r:embed="rId6"/>
+          <a:stretch>
+            <a:fillRect/>
+          </a:stretch>
+        </p:blipFill>
+        <p:spPr>
+          <a:xfrm>
+            <a:off x="1566710" y="1956816"/>
+            <a:ext cx="9058275" cy="1128712"/>
+          </a:xfrm>
+          <a:prstGeom prst="rect">
+            <a:avLst/>
+          </a:prstGeom>
+        </p:spPr>
+      </p:pic>
+      <p:sp>
+        <p:nvSpPr>
+          <p:cNvPr id="10" name="Rounded Rectangle 9"/>
+          <p:cNvSpPr/>
+          <p:nvPr/>
+        </p:nvSpPr>
+        <p:spPr>
+          <a:xfrm>
+            <a:off x="530352" y="3231832"/>
+            <a:ext cx="11130991" cy="1121664"/>
+          </a:xfrm>
+          <a:prstGeom prst="roundRect">
+            <a:avLst>
+              <a:gd name="adj" fmla="val 5000"/>
+            </a:avLst>
+          </a:prstGeom>
+          <a:solidFill>
+            <a:srgbClr val="F7F5FD"/>
+          </a:solidFill>
+          <a:ln w="9525">
+            <a:solidFill>
+              <a:srgbClr val="E4E1F1"/>
+            </a:solidFill>
+          </a:ln>
+          <a:effectLst>
+            <a:outerShdw blurRad="76200" dist="19050" dir="5400000" algn="bl" rotWithShape="0">
+              <a:srgbClr val="1A0F5C">
+                <a:alpha val="12000"/>
+              </a:srgbClr>
+            </a:outerShdw>
+          </a:effectLst>
+        </p:spPr>
+        <p:style>
+          <a:lnRef idx="1">
+            <a:schemeClr val="accent1"/>
+          </a:lnRef>
+          <a:fillRef idx="3">
+            <a:schemeClr val="accent1"/>
+          </a:fillRef>
+          <a:effectRef idx="2">
+            <a:schemeClr val="accent1"/>
+          </a:effectRef>
+          <a:fontRef idx="minor">
+            <a:schemeClr val="lt1"/>
+          </a:fontRef>
+        </p:style>
+        <p:txBody>
+          <a:bodyPr rtlCol="0" anchor="ctr" wrap="square"/>
+          <a:lstStyle/>
+          <a:p>
+            <a:pPr algn="ctr"/>
+          </a:p>
+        </p:txBody>
+      </p:sp>
+      <p:sp>
+        <p:nvSpPr>
+          <p:cNvPr id="11" name="Oval 10"/>
+          <p:cNvSpPr/>
+          <p:nvPr/>
+        </p:nvSpPr>
+        <p:spPr>
+          <a:xfrm>
+            <a:off x="758952" y="3564064"/>
+            <a:ext cx="457200" cy="457200"/>
+          </a:xfrm>
+          <a:prstGeom prst="ellipse">
+            <a:avLst/>
+          </a:prstGeom>
+          <a:solidFill>
+            <a:srgbClr val="5B3FD6"/>
+          </a:solidFill>
+          <a:ln>
+            <a:noFill/>
+          </a:ln>
+          <a:effectLst/>
+        </p:spPr>
+        <p:style>
+          <a:lnRef idx="1">
+            <a:schemeClr val="accent1"/>
+          </a:lnRef>
+          <a:fillRef idx="3">
+            <a:schemeClr val="accent1"/>
+          </a:fillRef>
+          <a:effectRef idx="2">
+            <a:schemeClr val="accent1"/>
+          </a:effectRef>
+          <a:fontRef idx="minor">
+            <a:schemeClr val="lt1"/>
+          </a:fontRef>
+        </p:style>
+        <p:txBody>
+          <a:bodyPr rtlCol="0" anchor="ctr" wrap="square"/>
+          <a:lstStyle/>
+          <a:p>
+            <a:pPr algn="ctr"/>
+          </a:p>
+        </p:txBody>
+      </p:sp>
+      <p:pic>
+        <p:nvPicPr>
+          <p:cNvPr id="12" name="Picture 11" descr="bug_39ada6eff46d.png"/>
+          <p:cNvPicPr>
+            <a:picLocks noChangeAspect="1"/>
+          </p:cNvPicPr>
+          <p:nvPr/>
+        </p:nvPicPr>
+        <p:blipFill>
+          <a:blip r:embed="rId5"/>
+          <a:stretch>
+            <a:fillRect/>
+          </a:stretch>
+        </p:blipFill>
+        <p:spPr>
+          <a:xfrm>
+            <a:off x="868680" y="3673792"/>
+            <a:ext cx="237744" cy="237744"/>
+          </a:xfrm>
+          <a:prstGeom prst="rect">
+            <a:avLst/>
+          </a:prstGeom>
+        </p:spPr>
+      </p:pic>
+      <p:sp>
+        <p:nvSpPr>
+          <p:cNvPr id="13" name="TextBox 12"/>
+          <p:cNvSpPr txBox="1"/>
+          <p:nvPr/>
+        </p:nvSpPr>
+        <p:spPr>
+          <a:xfrm>
+            <a:off x="1399031" y="3378136"/>
+            <a:ext cx="9987991" cy="160401"/>
+          </a:xfrm>
+          <a:prstGeom prst="rect">
+            <a:avLst/>
+          </a:prstGeom>
+          <a:noFill/>
+        </p:spPr>
+        <p:txBody>
+          <a:bodyPr wrap="square" anchor="t" lIns="0" rIns="0" tIns="0" bIns="0">
+            <a:spAutoFit/>
+          </a:bodyPr>
+          <a:lstStyle/>
+          <a:p>
+            <a:pPr algn="l"/>
+            <a:r>
+              <a:rPr sz="750" b="1" i="0" spc="250">
+                <a:solidFill>
+                  <a:srgbClr val="5B3FD6"/>
+                </a:solidFill>
+                <a:latin typeface="Calibri"/>
+              </a:rPr>
+              <a:t>WHAT BREAKS</a:t>
+            </a:r>
+          </a:p>
+        </p:txBody>
+      </p:sp>
+      <p:sp>
+        <p:nvSpPr>
+          <p:cNvPr id="14" name="TextBox 13"/>
+          <p:cNvSpPr txBox="1"/>
+          <p:nvPr/>
+        </p:nvSpPr>
+        <p:spPr>
+          <a:xfrm>
+            <a:off x="1399031" y="3597592"/>
+            <a:ext cx="9987991" cy="682752"/>
+          </a:xfrm>
+          <a:prstGeom prst="rect">
+            <a:avLst/>
+          </a:prstGeom>
+          <a:noFill/>
+        </p:spPr>
+        <p:txBody>
+          <a:bodyPr wrap="square" anchor="t" lIns="0" rIns="0" tIns="0" bIns="0">
+            <a:spAutoFit/>
+          </a:bodyPr>
+          <a:lstStyle/>
+          <a:p>
+            <a:r>
+              <a:rPr sz="1500" b="0" i="0">
+                <a:solidFill>
+                  <a:srgbClr val="1A1440"/>
+                </a:solidFill>
+                <a:latin typeface="Calibri"/>
+              </a:rPr>
+              <a:t>"p = 0.03, so there is a 3 percent chance we are wrong" reads as precise, sounds like probability, and sends Meera into Monday certain.</a:t>
+            </a:r>
+          </a:p>
+        </p:txBody>
+      </p:sp>
+      <p:sp>
+        <p:nvSpPr>
+          <p:cNvPr id="15" name="Oval 14"/>
+          <p:cNvSpPr/>
+          <p:nvPr/>
+        </p:nvSpPr>
+        <p:spPr>
+          <a:xfrm>
+            <a:off x="530352" y="6492240"/>
+            <a:ext cx="64008" cy="64008"/>
+          </a:xfrm>
+          <a:prstGeom prst="ellipse">
+            <a:avLst/>
+          </a:prstGeom>
+          <a:solidFill>
+            <a:srgbClr val="CFC9EE"/>
+          </a:solidFill>
+          <a:ln>
+            <a:noFill/>
+          </a:ln>
+          <a:effectLst/>
+        </p:spPr>
+        <p:style>
+          <a:lnRef idx="1">
+            <a:schemeClr val="accent1"/>
+          </a:lnRef>
+          <a:fillRef idx="3">
+            <a:schemeClr val="accent1"/>
+          </a:fillRef>
+          <a:effectRef idx="2">
+            <a:schemeClr val="accent1"/>
+          </a:effectRef>
+          <a:fontRef idx="minor">
+            <a:schemeClr val="lt1"/>
+          </a:fontRef>
+        </p:style>
+        <p:txBody>
+          <a:bodyPr rtlCol="0" anchor="ctr" wrap="square"/>
+          <a:lstStyle/>
+          <a:p>
+            <a:pPr algn="ctr"/>
+          </a:p>
+        </p:txBody>
+      </p:sp>
+      <p:sp>
+        <p:nvSpPr>
+          <p:cNvPr id="16" name="TextBox 15"/>
+          <p:cNvSpPr txBox="1"/>
+          <p:nvPr/>
+        </p:nvSpPr>
+        <p:spPr>
+          <a:xfrm>
+            <a:off x="640080" y="6437376"/>
+            <a:ext cx="596360" cy="152146"/>
+          </a:xfrm>
+          <a:prstGeom prst="rect">
+            <a:avLst/>
+          </a:prstGeom>
+          <a:noFill/>
+        </p:spPr>
+        <p:txBody>
+          <a:bodyPr wrap="square" anchor="t" lIns="0" rIns="0" tIns="0" bIns="0">
+            <a:spAutoFit/>
+          </a:bodyPr>
+          <a:lstStyle/>
+          <a:p>
+            <a:pPr algn="l"/>
+            <a:r>
+              <a:rPr sz="700" b="0" i="0">
+                <a:solidFill>
+                  <a:srgbClr val="6B6690"/>
+                </a:solidFill>
+                <a:latin typeface="Calibri"/>
+              </a:rPr>
+              <a:t>The ask</a:t>
+            </a:r>
+          </a:p>
+        </p:txBody>
+      </p:sp>
+      <p:sp>
+        <p:nvSpPr>
+          <p:cNvPr id="17" name="Oval 16"/>
+          <p:cNvSpPr/>
+          <p:nvPr/>
+        </p:nvSpPr>
+        <p:spPr>
+          <a:xfrm>
+            <a:off x="1327880" y="6492240"/>
+            <a:ext cx="64008" cy="64008"/>
+          </a:xfrm>
+          <a:prstGeom prst="ellipse">
+            <a:avLst/>
+          </a:prstGeom>
+          <a:solidFill>
+            <a:srgbClr val="5B3FD6"/>
+          </a:solidFill>
+          <a:ln>
+            <a:noFill/>
+          </a:ln>
+          <a:effectLst/>
+        </p:spPr>
+        <p:style>
+          <a:lnRef idx="1">
+            <a:schemeClr val="accent1"/>
+          </a:lnRef>
+          <a:fillRef idx="3">
+            <a:schemeClr val="accent1"/>
+          </a:fillRef>
+          <a:effectRef idx="2">
+            <a:schemeClr val="accent1"/>
+          </a:effectRef>
+          <a:fontRef idx="minor">
+            <a:schemeClr val="lt1"/>
+          </a:fontRef>
+        </p:style>
+        <p:txBody>
+          <a:bodyPr rtlCol="0" anchor="ctr" wrap="square"/>
+          <a:lstStyle/>
+          <a:p>
+            <a:pPr algn="ctr"/>
+          </a:p>
+        </p:txBody>
+      </p:sp>
+      <p:sp>
+        <p:nvSpPr>
+          <p:cNvPr id="18" name="TextBox 17"/>
+          <p:cNvSpPr txBox="1"/>
+          <p:nvPr/>
+        </p:nvSpPr>
+        <p:spPr>
+          <a:xfrm>
+            <a:off x="1437608" y="6437376"/>
+            <a:ext cx="1562480" cy="152146"/>
+          </a:xfrm>
+          <a:prstGeom prst="rect">
+            <a:avLst/>
+          </a:prstGeom>
+          <a:noFill/>
+        </p:spPr>
+        <p:txBody>
+          <a:bodyPr wrap="square" anchor="t" lIns="0" rIns="0" tIns="0" bIns="0">
+            <a:spAutoFit/>
+          </a:bodyPr>
+          <a:lstStyle/>
+          <a:p>
+            <a:pPr algn="l"/>
+            <a:r>
+              <a:rPr sz="700" b="1" i="0">
+                <a:solidFill>
+                  <a:srgbClr val="5B3FD6"/>
+                </a:solidFill>
+                <a:latin typeface="Calibri"/>
+              </a:rPr>
+              <a:t>Round 1. Real, or the wobble</a:t>
+            </a:r>
+          </a:p>
+        </p:txBody>
+      </p:sp>
+      <p:sp>
+        <p:nvSpPr>
+          <p:cNvPr id="19" name="Oval 18"/>
+          <p:cNvSpPr/>
+          <p:nvPr/>
+        </p:nvSpPr>
+        <p:spPr>
+          <a:xfrm>
+            <a:off x="3091529" y="6492240"/>
+            <a:ext cx="64008" cy="64008"/>
+          </a:xfrm>
+          <a:prstGeom prst="ellipse">
+            <a:avLst/>
+          </a:prstGeom>
+          <a:solidFill>
+            <a:srgbClr val="CFC9EE"/>
+          </a:solidFill>
+          <a:ln>
+            <a:noFill/>
+          </a:ln>
+          <a:effectLst/>
+        </p:spPr>
+        <p:style>
+          <a:lnRef idx="1">
+            <a:schemeClr val="accent1"/>
+          </a:lnRef>
+          <a:fillRef idx="3">
+            <a:schemeClr val="accent1"/>
+          </a:fillRef>
+          <a:effectRef idx="2">
+            <a:schemeClr val="accent1"/>
+          </a:effectRef>
+          <a:fontRef idx="minor">
+            <a:schemeClr val="lt1"/>
+          </a:fontRef>
+        </p:style>
+        <p:txBody>
+          <a:bodyPr rtlCol="0" anchor="ctr" wrap="square"/>
+          <a:lstStyle/>
+          <a:p>
+            <a:pPr algn="ctr"/>
+          </a:p>
+        </p:txBody>
+      </p:sp>
+      <p:sp>
+        <p:nvSpPr>
+          <p:cNvPr id="20" name="TextBox 19"/>
+          <p:cNvSpPr txBox="1"/>
+          <p:nvPr/>
+        </p:nvSpPr>
+        <p:spPr>
+          <a:xfrm>
+            <a:off x="3201257" y="6437376"/>
+            <a:ext cx="1378457" cy="152146"/>
+          </a:xfrm>
+          <a:prstGeom prst="rect">
+            <a:avLst/>
+          </a:prstGeom>
+          <a:noFill/>
+        </p:spPr>
+        <p:txBody>
+          <a:bodyPr wrap="square" anchor="t" lIns="0" rIns="0" tIns="0" bIns="0">
+            <a:spAutoFit/>
+          </a:bodyPr>
+          <a:lstStyle/>
+          <a:p>
+            <a:pPr algn="l"/>
+            <a:r>
+              <a:rPr sz="700" b="0" i="0">
+                <a:solidFill>
+                  <a:srgbClr val="6B6690"/>
+                </a:solidFill>
+                <a:latin typeface="Calibri"/>
+              </a:rPr>
+              <a:t>Round 2. Worth acting on</a:t>
+            </a:r>
+          </a:p>
+        </p:txBody>
+      </p:sp>
+      <p:sp>
+        <p:nvSpPr>
+          <p:cNvPr id="21" name="Oval 20"/>
+          <p:cNvSpPr/>
+          <p:nvPr/>
+        </p:nvSpPr>
+        <p:spPr>
+          <a:xfrm>
+            <a:off x="4671155" y="6492240"/>
+            <a:ext cx="64008" cy="64008"/>
+          </a:xfrm>
+          <a:prstGeom prst="ellipse">
+            <a:avLst/>
+          </a:prstGeom>
+          <a:solidFill>
+            <a:srgbClr val="CFC9EE"/>
+          </a:solidFill>
+          <a:ln>
+            <a:noFill/>
+          </a:ln>
+          <a:effectLst/>
+        </p:spPr>
+        <p:style>
+          <a:lnRef idx="1">
+            <a:schemeClr val="accent1"/>
+          </a:lnRef>
+          <a:fillRef idx="3">
+            <a:schemeClr val="accent1"/>
+          </a:fillRef>
+          <a:effectRef idx="2">
+            <a:schemeClr val="accent1"/>
+          </a:effectRef>
+          <a:fontRef idx="minor">
+            <a:schemeClr val="lt1"/>
+          </a:fontRef>
+        </p:style>
+        <p:txBody>
+          <a:bodyPr rtlCol="0" anchor="ctr" wrap="square"/>
+          <a:lstStyle/>
+          <a:p>
+            <a:pPr algn="ctr"/>
+          </a:p>
+        </p:txBody>
+      </p:sp>
+      <p:sp>
+        <p:nvSpPr>
+          <p:cNvPr id="22" name="TextBox 21"/>
+          <p:cNvSpPr txBox="1"/>
+          <p:nvPr/>
+        </p:nvSpPr>
+        <p:spPr>
+          <a:xfrm>
+            <a:off x="4780883" y="6437376"/>
+            <a:ext cx="1930527" cy="152146"/>
+          </a:xfrm>
+          <a:prstGeom prst="rect">
+            <a:avLst/>
+          </a:prstGeom>
+          <a:noFill/>
+        </p:spPr>
+        <p:txBody>
+          <a:bodyPr wrap="square" anchor="t" lIns="0" rIns="0" tIns="0" bIns="0">
+            <a:spAutoFit/>
+          </a:bodyPr>
+          <a:lstStyle/>
+          <a:p>
+            <a:pPr algn="l"/>
+            <a:r>
+              <a:rPr sz="700" b="0" i="0">
+                <a:solidFill>
+                  <a:srgbClr val="6B6690"/>
+                </a:solidFill>
+                <a:latin typeface="Calibri"/>
+              </a:rPr>
+              <a:t>Round 3. The count behind 40 percent</a:t>
+            </a:r>
+          </a:p>
+        </p:txBody>
+      </p:sp>
+      <p:sp>
+        <p:nvSpPr>
+          <p:cNvPr id="23" name="TextBox 22"/>
+          <p:cNvSpPr txBox="1"/>
+          <p:nvPr/>
+        </p:nvSpPr>
+        <p:spPr>
+          <a:xfrm>
+            <a:off x="10198303" y="6437376"/>
+            <a:ext cx="1463040" cy="160401"/>
+          </a:xfrm>
+          <a:prstGeom prst="rect">
+            <a:avLst/>
+          </a:prstGeom>
+          <a:noFill/>
+        </p:spPr>
+        <p:txBody>
+          <a:bodyPr wrap="square" anchor="t" lIns="0" rIns="0" tIns="0" bIns="0">
+            <a:spAutoFit/>
+          </a:bodyPr>
+          <a:lstStyle/>
+          <a:p>
+            <a:pPr algn="r"/>
+            <a:r>
+              <a:rPr sz="750" b="0" i="0">
+                <a:solidFill>
+                  <a:srgbClr val="6B6690"/>
+                </a:solidFill>
+                <a:latin typeface="Calibri"/>
+              </a:rPr>
+              <a:t>S14  ·  17 / 44</a:t>
+            </a:r>
+          </a:p>
+        </p:txBody>
+      </p:sp>
+    </p:spTree>
+  </p:cSld>
+  <p:clrMapOvr>
+    <a:masterClrMapping/>
+  </p:clrMapOvr>
+</p:sld>
+</file>
+
+<file path=ppt/slides/slide18.xml><?xml version="1.0" encoding="utf-8"?>
+<p:sld xmlns:a="http://schemas.openxmlformats.org/drawingml/2006/main" xmlns:p="http://schemas.openxmlformats.org/presentationml/2006/main" xmlns:r="http://schemas.openxmlformats.org/officeDocument/2006/relationships">
+  <p:cSld>
+    <p:spTree>
+      <p:nvGrpSpPr>
+        <p:cNvPr id="1" name=""/>
+        <p:cNvGrpSpPr/>
+        <p:nvPr/>
+      </p:nvGrpSpPr>
+      <p:grpSpPr/>
+      <p:pic>
+        <p:nvPicPr>
+          <p:cNvPr id="2" name="Picture 1" descr="bg_light.jpg"/>
+          <p:cNvPicPr>
+            <a:picLocks noChangeAspect="1"/>
+          </p:cNvPicPr>
+          <p:nvPr/>
+        </p:nvPicPr>
+        <p:blipFill>
+          <a:blip r:embed="rId2"/>
+          <a:stretch>
+            <a:fillRect/>
+          </a:stretch>
+        </p:blipFill>
+        <p:spPr>
+          <a:xfrm>
+            <a:off x="0" y="0"/>
+            <a:ext cx="12191695" cy="6858000"/>
+          </a:xfrm>
+          <a:prstGeom prst="rect">
+            <a:avLst/>
+          </a:prstGeom>
+        </p:spPr>
+      </p:pic>
+      <p:pic>
+        <p:nvPicPr>
+          <p:cNvPr id="3" name="Picture 2" descr="iitgn_logo.png"/>
+          <p:cNvPicPr>
+            <a:picLocks noChangeAspect="1"/>
+          </p:cNvPicPr>
+          <p:nvPr/>
+        </p:nvPicPr>
+        <p:blipFill>
+          <a:blip r:embed="rId3"/>
+          <a:stretch>
+            <a:fillRect/>
+          </a:stretch>
+        </p:blipFill>
+        <p:spPr>
+          <a:xfrm>
+            <a:off x="530352" y="201168"/>
+            <a:ext cx="420624" cy="420624"/>
+          </a:xfrm>
+          <a:prstGeom prst="rect">
+            <a:avLst/>
+          </a:prstGeom>
+        </p:spPr>
+      </p:pic>
+      <p:sp>
+        <p:nvSpPr>
+          <p:cNvPr id="4" name="TextBox 3"/>
+          <p:cNvSpPr txBox="1"/>
+          <p:nvPr/>
+        </p:nvSpPr>
+        <p:spPr>
+          <a:xfrm>
+            <a:off x="1042416" y="228600"/>
+            <a:ext cx="5120640" cy="185166"/>
+          </a:xfrm>
+          <a:prstGeom prst="rect">
+            <a:avLst/>
+          </a:prstGeom>
+          <a:noFill/>
+        </p:spPr>
+        <p:txBody>
+          <a:bodyPr wrap="square" anchor="t" lIns="0" rIns="0" tIns="0" bIns="0">
+            <a:spAutoFit/>
+          </a:bodyPr>
+          <a:lstStyle/>
+          <a:p>
+            <a:pPr algn="l"/>
+            <a:r>
+              <a:rPr sz="900" b="1" i="0">
+                <a:solidFill>
+                  <a:srgbClr val="1A0F5C"/>
+                </a:solidFill>
+                <a:latin typeface="Calibri"/>
+              </a:rPr>
+              <a:t>Indian Institute of Technology Gandhinagar</a:t>
+            </a:r>
+          </a:p>
+        </p:txBody>
+      </p:sp>
+      <p:sp>
+        <p:nvSpPr>
+          <p:cNvPr id="5" name="TextBox 4"/>
+          <p:cNvSpPr txBox="1"/>
+          <p:nvPr/>
+        </p:nvSpPr>
+        <p:spPr>
+          <a:xfrm>
+            <a:off x="1042416" y="420623"/>
+            <a:ext cx="5852160" cy="127381"/>
+          </a:xfrm>
+          <a:prstGeom prst="rect">
+            <a:avLst/>
+          </a:prstGeom>
+          <a:noFill/>
+        </p:spPr>
+        <p:txBody>
+          <a:bodyPr wrap="square" anchor="t" lIns="0" rIns="0" tIns="0" bIns="0">
+            <a:spAutoFit/>
+          </a:bodyPr>
+          <a:lstStyle/>
+          <a:p>
+            <a:pPr algn="l"/>
+            <a:r>
+              <a:rPr sz="550" b="1" i="0" spc="300">
+                <a:solidFill>
+                  <a:srgbClr val="6B6690"/>
+                </a:solidFill>
+                <a:latin typeface="Calibri"/>
+              </a:rPr>
+              <a:t>ADMINISTERED THROUGH THE COMPETENCY ADVANCEMENT ACADEMY</a:t>
+            </a:r>
+          </a:p>
+        </p:txBody>
+      </p:sp>
+      <p:sp>
+        <p:nvSpPr>
+          <p:cNvPr id="6" name="TextBox 5"/>
+          <p:cNvSpPr txBox="1"/>
+          <p:nvPr/>
+        </p:nvSpPr>
+        <p:spPr>
+          <a:xfrm>
+            <a:off x="5992063" y="310896"/>
+            <a:ext cx="5669280" cy="127381"/>
+          </a:xfrm>
+          <a:prstGeom prst="rect">
+            <a:avLst/>
+          </a:prstGeom>
+          <a:noFill/>
+        </p:spPr>
+        <p:txBody>
+          <a:bodyPr wrap="square" anchor="t" lIns="0" rIns="0" tIns="0" bIns="0">
+            <a:spAutoFit/>
+          </a:bodyPr>
+          <a:lstStyle/>
+          <a:p>
+            <a:pPr algn="r"/>
+            <a:r>
+              <a:rPr sz="550" b="1" i="0" spc="300">
+                <a:solidFill>
+                  <a:srgbClr val="6B6690"/>
+                </a:solidFill>
+                <a:latin typeface="Calibri"/>
+              </a:rPr>
+              <a:t>WEEK 1  ·  DAY 4  ·  KALPA GLOBAL CAPABILITY CENTRE</a:t>
+            </a:r>
+          </a:p>
+        </p:txBody>
+      </p:sp>
+      <p:sp>
+        <p:nvSpPr>
+          <p:cNvPr id="7" name="TextBox 6"/>
+          <p:cNvSpPr txBox="1"/>
+          <p:nvPr/>
+        </p:nvSpPr>
+        <p:spPr>
+          <a:xfrm>
+            <a:off x="530352" y="676656"/>
+            <a:ext cx="11130991" cy="512064"/>
+          </a:xfrm>
+          <a:prstGeom prst="rect">
+            <a:avLst/>
+          </a:prstGeom>
+          <a:noFill/>
+        </p:spPr>
+        <p:txBody>
+          <a:bodyPr wrap="square" anchor="b" lIns="0" rIns="0" tIns="0" bIns="0">
+            <a:spAutoFit/>
+          </a:bodyPr>
+          <a:lstStyle/>
+          <a:p>
+            <a:pPr algn="l"/>
+            <a:r>
+              <a:rPr sz="2600" b="0" i="0">
+                <a:solidFill>
+                  <a:srgbClr val="1A0F5C"/>
+                </a:solidFill>
+                <a:latin typeface="Georgia"/>
+              </a:rPr>
               <a:t>Why it is wrong: the share was counted under chance</a:t>
             </a:r>
           </a:p>
@@ -14628,7 +16097,7 @@
                 </a:solidFill>
                 <a:latin typeface="Calibri"/>
               </a:rPr>
-              <a:t>S14  ·  17 / 44</a:t>
+              <a:t>S15  ·  18 / 44</a:t>
             </a:r>
           </a:p>
         </p:txBody>
@@ -14641,7 +16110,7 @@
 </p:sld>
 </file>
 
-<file path=ppt/slides/slide18.xml><?xml version="1.0" encoding="utf-8"?>
+<file path=ppt/slides/slide19.xml><?xml version="1.0" encoding="utf-8"?>
 <p:sld xmlns:a="http://schemas.openxmlformats.org/drawingml/2006/main" xmlns:p="http://schemas.openxmlformats.org/presentationml/2006/main" xmlns:r="http://schemas.openxmlformats.org/officeDocument/2006/relationships">
   <p:cSld>
     <p:spTree>
@@ -15621,1460 +17090,6 @@
                 </a:solidFill>
                 <a:latin typeface="Calibri"/>
               </a:rPr>
-              <a:t>S15  ·  18 / 44</a:t>
-            </a:r>
-          </a:p>
-        </p:txBody>
-      </p:sp>
-    </p:spTree>
-  </p:cSld>
-  <p:clrMapOvr>
-    <a:masterClrMapping/>
-  </p:clrMapOvr>
-</p:sld>
-</file>
-
-<file path=ppt/slides/slide19.xml><?xml version="1.0" encoding="utf-8"?>
-<p:sld xmlns:a="http://schemas.openxmlformats.org/drawingml/2006/main" xmlns:p="http://schemas.openxmlformats.org/presentationml/2006/main" xmlns:r="http://schemas.openxmlformats.org/officeDocument/2006/relationships">
-  <p:cSld>
-    <p:spTree>
-      <p:nvGrpSpPr>
-        <p:cNvPr id="1" name=""/>
-        <p:cNvGrpSpPr/>
-        <p:nvPr/>
-      </p:nvGrpSpPr>
-      <p:grpSpPr/>
-      <p:pic>
-        <p:nvPicPr>
-          <p:cNvPr id="2" name="Picture 1" descr="bg_light.jpg"/>
-          <p:cNvPicPr>
-            <a:picLocks noChangeAspect="1"/>
-          </p:cNvPicPr>
-          <p:nvPr/>
-        </p:nvPicPr>
-        <p:blipFill>
-          <a:blip r:embed="rId2"/>
-          <a:stretch>
-            <a:fillRect/>
-          </a:stretch>
-        </p:blipFill>
-        <p:spPr>
-          <a:xfrm>
-            <a:off x="0" y="0"/>
-            <a:ext cx="12191695" cy="6858000"/>
-          </a:xfrm>
-          <a:prstGeom prst="rect">
-            <a:avLst/>
-          </a:prstGeom>
-        </p:spPr>
-      </p:pic>
-      <p:pic>
-        <p:nvPicPr>
-          <p:cNvPr id="3" name="Picture 2" descr="iitgn_logo.png"/>
-          <p:cNvPicPr>
-            <a:picLocks noChangeAspect="1"/>
-          </p:cNvPicPr>
-          <p:nvPr/>
-        </p:nvPicPr>
-        <p:blipFill>
-          <a:blip r:embed="rId3"/>
-          <a:stretch>
-            <a:fillRect/>
-          </a:stretch>
-        </p:blipFill>
-        <p:spPr>
-          <a:xfrm>
-            <a:off x="530352" y="201168"/>
-            <a:ext cx="420624" cy="420624"/>
-          </a:xfrm>
-          <a:prstGeom prst="rect">
-            <a:avLst/>
-          </a:prstGeom>
-        </p:spPr>
-      </p:pic>
-      <p:sp>
-        <p:nvSpPr>
-          <p:cNvPr id="4" name="TextBox 3"/>
-          <p:cNvSpPr txBox="1"/>
-          <p:nvPr/>
-        </p:nvSpPr>
-        <p:spPr>
-          <a:xfrm>
-            <a:off x="1042416" y="228600"/>
-            <a:ext cx="5120640" cy="185166"/>
-          </a:xfrm>
-          <a:prstGeom prst="rect">
-            <a:avLst/>
-          </a:prstGeom>
-          <a:noFill/>
-        </p:spPr>
-        <p:txBody>
-          <a:bodyPr wrap="square" anchor="t" lIns="0" rIns="0" tIns="0" bIns="0">
-            <a:spAutoFit/>
-          </a:bodyPr>
-          <a:lstStyle/>
-          <a:p>
-            <a:pPr algn="l"/>
-            <a:r>
-              <a:rPr sz="900" b="1" i="0">
-                <a:solidFill>
-                  <a:srgbClr val="1A0F5C"/>
-                </a:solidFill>
-                <a:latin typeface="Calibri"/>
-              </a:rPr>
-              <a:t>Indian Institute of Technology Gandhinagar</a:t>
-            </a:r>
-          </a:p>
-        </p:txBody>
-      </p:sp>
-      <p:sp>
-        <p:nvSpPr>
-          <p:cNvPr id="5" name="TextBox 4"/>
-          <p:cNvSpPr txBox="1"/>
-          <p:nvPr/>
-        </p:nvSpPr>
-        <p:spPr>
-          <a:xfrm>
-            <a:off x="1042416" y="420623"/>
-            <a:ext cx="5852160" cy="127381"/>
-          </a:xfrm>
-          <a:prstGeom prst="rect">
-            <a:avLst/>
-          </a:prstGeom>
-          <a:noFill/>
-        </p:spPr>
-        <p:txBody>
-          <a:bodyPr wrap="square" anchor="t" lIns="0" rIns="0" tIns="0" bIns="0">
-            <a:spAutoFit/>
-          </a:bodyPr>
-          <a:lstStyle/>
-          <a:p>
-            <a:pPr algn="l"/>
-            <a:r>
-              <a:rPr sz="550" b="1" i="0" spc="300">
-                <a:solidFill>
-                  <a:srgbClr val="6B6690"/>
-                </a:solidFill>
-                <a:latin typeface="Calibri"/>
-              </a:rPr>
-              <a:t>ADMINISTERED THROUGH THE COMPETENCY ADVANCEMENT ACADEMY</a:t>
-            </a:r>
-          </a:p>
-        </p:txBody>
-      </p:sp>
-      <p:sp>
-        <p:nvSpPr>
-          <p:cNvPr id="6" name="TextBox 5"/>
-          <p:cNvSpPr txBox="1"/>
-          <p:nvPr/>
-        </p:nvSpPr>
-        <p:spPr>
-          <a:xfrm>
-            <a:off x="5992063" y="310896"/>
-            <a:ext cx="5669280" cy="127381"/>
-          </a:xfrm>
-          <a:prstGeom prst="rect">
-            <a:avLst/>
-          </a:prstGeom>
-          <a:noFill/>
-        </p:spPr>
-        <p:txBody>
-          <a:bodyPr wrap="square" anchor="t" lIns="0" rIns="0" tIns="0" bIns="0">
-            <a:spAutoFit/>
-          </a:bodyPr>
-          <a:lstStyle/>
-          <a:p>
-            <a:pPr algn="r"/>
-            <a:r>
-              <a:rPr sz="550" b="1" i="0" spc="300">
-                <a:solidFill>
-                  <a:srgbClr val="6B6690"/>
-                </a:solidFill>
-                <a:latin typeface="Calibri"/>
-              </a:rPr>
-              <a:t>WEEK 1  ·  DAY 4  ·  KALPA GLOBAL CAPABILITY CENTRE</a:t>
-            </a:r>
-          </a:p>
-        </p:txBody>
-      </p:sp>
-      <p:sp>
-        <p:nvSpPr>
-          <p:cNvPr id="7" name="TextBox 6"/>
-          <p:cNvSpPr txBox="1"/>
-          <p:nvPr/>
-        </p:nvSpPr>
-        <p:spPr>
-          <a:xfrm>
-            <a:off x="530352" y="676656"/>
-            <a:ext cx="11130991" cy="512064"/>
-          </a:xfrm>
-          <a:prstGeom prst="rect">
-            <a:avLst/>
-          </a:prstGeom>
-          <a:noFill/>
-        </p:spPr>
-        <p:txBody>
-          <a:bodyPr wrap="square" anchor="b" lIns="0" rIns="0" tIns="0" bIns="0">
-            <a:spAutoFit/>
-          </a:bodyPr>
-          <a:lstStyle/>
-          <a:p>
-            <a:pPr algn="l"/>
-            <a:r>
-              <a:rPr sz="2600" b="0" i="0">
-                <a:solidFill>
-                  <a:srgbClr val="1A0F5C"/>
-                </a:solidFill>
-                <a:latin typeface="Georgia"/>
-              </a:rPr>
-              <a:t>Your turn: Retail-Plus, 5,000 shuffles</a:t>
-            </a:r>
-          </a:p>
-        </p:txBody>
-      </p:sp>
-      <p:sp>
-        <p:nvSpPr>
-          <p:cNvPr id="8" name="TextBox 7"/>
-          <p:cNvSpPr txBox="1"/>
-          <p:nvPr/>
-        </p:nvSpPr>
-        <p:spPr>
-          <a:xfrm>
-            <a:off x="530352" y="1243584"/>
-            <a:ext cx="11130991" cy="234696"/>
-          </a:xfrm>
-          <a:prstGeom prst="rect">
-            <a:avLst/>
-          </a:prstGeom>
-          <a:noFill/>
-        </p:spPr>
-        <p:txBody>
-          <a:bodyPr wrap="square" anchor="t" lIns="0" rIns="0" tIns="0" bIns="0">
-            <a:spAutoFit/>
-          </a:bodyPr>
-          <a:lstStyle/>
-          <a:p>
-            <a:pPr algn="l"/>
-            <a:r>
-              <a:rPr sz="1200" b="0" i="0">
-                <a:solidFill>
-                  <a:srgbClr val="6B6690"/>
-                </a:solidFill>
-                <a:latin typeface="Calibri"/>
-              </a:rPr>
-              <a:t>The same loop on the segment Meera asked about, run by the room, with the sentence written after.</a:t>
-            </a:r>
-          </a:p>
-        </p:txBody>
-      </p:sp>
-      <p:sp>
-        <p:nvSpPr>
-          <p:cNvPr id="9" name="Rectangle 8"/>
-          <p:cNvSpPr/>
-          <p:nvPr/>
-        </p:nvSpPr>
-        <p:spPr>
-          <a:xfrm>
-            <a:off x="1853145" y="2523744"/>
-            <a:ext cx="8485403" cy="18288"/>
-          </a:xfrm>
-          <a:prstGeom prst="rect">
-            <a:avLst/>
-          </a:prstGeom>
-          <a:solidFill>
-            <a:srgbClr val="CFC9EE"/>
-          </a:solidFill>
-          <a:ln>
-            <a:noFill/>
-          </a:ln>
-          <a:effectLst/>
-        </p:spPr>
-        <p:style>
-          <a:lnRef idx="1">
-            <a:schemeClr val="accent1"/>
-          </a:lnRef>
-          <a:fillRef idx="3">
-            <a:schemeClr val="accent1"/>
-          </a:fillRef>
-          <a:effectRef idx="2">
-            <a:schemeClr val="accent1"/>
-          </a:effectRef>
-          <a:fontRef idx="minor">
-            <a:schemeClr val="lt1"/>
-          </a:fontRef>
-        </p:style>
-        <p:txBody>
-          <a:bodyPr rtlCol="0" anchor="ctr" wrap="square"/>
-          <a:lstStyle/>
-          <a:p>
-            <a:pPr algn="ctr"/>
-          </a:p>
-        </p:txBody>
-      </p:sp>
-      <p:sp>
-        <p:nvSpPr>
-          <p:cNvPr id="10" name="TextBox 9"/>
-          <p:cNvSpPr txBox="1"/>
-          <p:nvPr/>
-        </p:nvSpPr>
-        <p:spPr>
-          <a:xfrm>
-            <a:off x="530352" y="1956816"/>
-            <a:ext cx="2645587" cy="168656"/>
-          </a:xfrm>
-          <a:prstGeom prst="rect">
-            <a:avLst/>
-          </a:prstGeom>
-          <a:noFill/>
-        </p:spPr>
-        <p:txBody>
-          <a:bodyPr wrap="square" anchor="t" lIns="0" rIns="0" tIns="0" bIns="0">
-            <a:spAutoFit/>
-          </a:bodyPr>
-          <a:lstStyle/>
-          <a:p>
-            <a:pPr algn="ctr"/>
-            <a:r>
-              <a:rPr sz="800" b="1" i="0" spc="250">
-                <a:solidFill>
-                  <a:srgbClr val="5B3FD6"/>
-                </a:solidFill>
-                <a:latin typeface="Calibri"/>
-              </a:rPr>
-              <a:t>STEP 1</a:t>
-            </a:r>
-          </a:p>
-        </p:txBody>
-      </p:sp>
-      <p:sp>
-        <p:nvSpPr>
-          <p:cNvPr id="11" name="Oval 10"/>
-          <p:cNvSpPr/>
-          <p:nvPr/>
-        </p:nvSpPr>
-        <p:spPr>
-          <a:xfrm>
-            <a:off x="1752561" y="2432304"/>
-            <a:ext cx="201168" cy="201168"/>
-          </a:xfrm>
-          <a:prstGeom prst="ellipse">
-            <a:avLst/>
-          </a:prstGeom>
-          <a:solidFill>
-            <a:srgbClr val="5B3FD6"/>
-          </a:solidFill>
-          <a:ln>
-            <a:noFill/>
-          </a:ln>
-          <a:effectLst/>
-        </p:spPr>
-        <p:style>
-          <a:lnRef idx="1">
-            <a:schemeClr val="accent1"/>
-          </a:lnRef>
-          <a:fillRef idx="3">
-            <a:schemeClr val="accent1"/>
-          </a:fillRef>
-          <a:effectRef idx="2">
-            <a:schemeClr val="accent1"/>
-          </a:effectRef>
-          <a:fontRef idx="minor">
-            <a:schemeClr val="lt1"/>
-          </a:fontRef>
-        </p:style>
-        <p:txBody>
-          <a:bodyPr rtlCol="0" anchor="ctr" wrap="square"/>
-          <a:lstStyle/>
-          <a:p>
-            <a:pPr algn="ctr"/>
-          </a:p>
-        </p:txBody>
-      </p:sp>
-      <p:sp>
-        <p:nvSpPr>
-          <p:cNvPr id="12" name="Rounded Rectangle 11"/>
-          <p:cNvSpPr/>
-          <p:nvPr/>
-        </p:nvSpPr>
-        <p:spPr>
-          <a:xfrm>
-            <a:off x="530352" y="2843784"/>
-            <a:ext cx="2645587" cy="1249680"/>
-          </a:xfrm>
-          <a:prstGeom prst="roundRect">
-            <a:avLst>
-              <a:gd name="adj" fmla="val 5000"/>
-            </a:avLst>
-          </a:prstGeom>
-          <a:solidFill>
-            <a:srgbClr val="FFFFFF"/>
-          </a:solidFill>
-          <a:ln w="9525">
-            <a:solidFill>
-              <a:srgbClr val="E4E1F1"/>
-            </a:solidFill>
-          </a:ln>
-          <a:effectLst>
-            <a:outerShdw blurRad="76200" dist="19050" dir="5400000" algn="bl" rotWithShape="0">
-              <a:srgbClr val="1A0F5C">
-                <a:alpha val="12000"/>
-              </a:srgbClr>
-            </a:outerShdw>
-          </a:effectLst>
-        </p:spPr>
-        <p:style>
-          <a:lnRef idx="1">
-            <a:schemeClr val="accent1"/>
-          </a:lnRef>
-          <a:fillRef idx="3">
-            <a:schemeClr val="accent1"/>
-          </a:fillRef>
-          <a:effectRef idx="2">
-            <a:schemeClr val="accent1"/>
-          </a:effectRef>
-          <a:fontRef idx="minor">
-            <a:schemeClr val="lt1"/>
-          </a:fontRef>
-        </p:style>
-        <p:txBody>
-          <a:bodyPr rtlCol="0" anchor="ctr" wrap="square"/>
-          <a:lstStyle/>
-          <a:p>
-            <a:pPr algn="ctr"/>
-          </a:p>
-        </p:txBody>
-      </p:sp>
-      <p:sp>
-        <p:nvSpPr>
-          <p:cNvPr id="13" name="TextBox 12"/>
-          <p:cNvSpPr txBox="1"/>
-          <p:nvPr/>
-        </p:nvSpPr>
-        <p:spPr>
-          <a:xfrm>
-            <a:off x="694944" y="2990088"/>
-            <a:ext cx="2316403" cy="251205"/>
-          </a:xfrm>
-          <a:prstGeom prst="rect">
-            <a:avLst/>
-          </a:prstGeom>
-          <a:noFill/>
-        </p:spPr>
-        <p:txBody>
-          <a:bodyPr wrap="square" anchor="t" lIns="0" rIns="0" tIns="0" bIns="0">
-            <a:spAutoFit/>
-          </a:bodyPr>
-          <a:lstStyle/>
-          <a:p>
-            <a:pPr algn="l"/>
-            <a:r>
-              <a:rPr sz="1300" b="1" i="0">
-                <a:solidFill>
-                  <a:srgbClr val="1A0F5C"/>
-                </a:solidFill>
-                <a:latin typeface="Calibri"/>
-              </a:rPr>
-              <a:t>The measure</a:t>
-            </a:r>
-          </a:p>
-        </p:txBody>
-      </p:sp>
-      <p:sp>
-        <p:nvSpPr>
-          <p:cNvPr id="14" name="TextBox 13"/>
-          <p:cNvSpPr txBox="1"/>
-          <p:nvPr/>
-        </p:nvSpPr>
-        <p:spPr>
-          <a:xfrm>
-            <a:off x="694944" y="3277870"/>
-            <a:ext cx="2316403" cy="531876"/>
-          </a:xfrm>
-          <a:prstGeom prst="rect">
-            <a:avLst/>
-          </a:prstGeom>
-          <a:noFill/>
-        </p:spPr>
-        <p:txBody>
-          <a:bodyPr wrap="square" anchor="t" lIns="0" rIns="0" tIns="0" bIns="0">
-            <a:spAutoFit/>
-          </a:bodyPr>
-          <a:lstStyle/>
-          <a:p>
-            <a:pPr algn="l"/>
-            <a:r>
-              <a:rPr sz="1000" b="0" i="0">
-                <a:solidFill>
-                  <a:srgbClr val="6B6690"/>
-                </a:solidFill>
-                <a:latin typeface="Calibri"/>
-              </a:rPr>
-              <a:t>Delivered revenue per Retail-Plus member, Q1 and Q2, from notebook 1, level 4.</a:t>
-            </a:r>
-          </a:p>
-        </p:txBody>
-      </p:sp>
-      <p:sp>
-        <p:nvSpPr>
-          <p:cNvPr id="15" name="TextBox 14"/>
-          <p:cNvSpPr txBox="1"/>
-          <p:nvPr/>
-        </p:nvSpPr>
-        <p:spPr>
-          <a:xfrm>
-            <a:off x="3358819" y="1956816"/>
-            <a:ext cx="2645587" cy="168656"/>
-          </a:xfrm>
-          <a:prstGeom prst="rect">
-            <a:avLst/>
-          </a:prstGeom>
-          <a:noFill/>
-        </p:spPr>
-        <p:txBody>
-          <a:bodyPr wrap="square" anchor="t" lIns="0" rIns="0" tIns="0" bIns="0">
-            <a:spAutoFit/>
-          </a:bodyPr>
-          <a:lstStyle/>
-          <a:p>
-            <a:pPr algn="ctr"/>
-            <a:r>
-              <a:rPr sz="800" b="1" i="0" spc="250">
-                <a:solidFill>
-                  <a:srgbClr val="5B3FD6"/>
-                </a:solidFill>
-                <a:latin typeface="Calibri"/>
-              </a:rPr>
-              <a:t>STEP 2</a:t>
-            </a:r>
-          </a:p>
-        </p:txBody>
-      </p:sp>
-      <p:sp>
-        <p:nvSpPr>
-          <p:cNvPr id="16" name="Oval 15"/>
-          <p:cNvSpPr/>
-          <p:nvPr/>
-        </p:nvSpPr>
-        <p:spPr>
-          <a:xfrm>
-            <a:off x="4581029" y="2432304"/>
-            <a:ext cx="201168" cy="201168"/>
-          </a:xfrm>
-          <a:prstGeom prst="ellipse">
-            <a:avLst/>
-          </a:prstGeom>
-          <a:solidFill>
-            <a:srgbClr val="5B3FD6"/>
-          </a:solidFill>
-          <a:ln>
-            <a:noFill/>
-          </a:ln>
-          <a:effectLst/>
-        </p:spPr>
-        <p:style>
-          <a:lnRef idx="1">
-            <a:schemeClr val="accent1"/>
-          </a:lnRef>
-          <a:fillRef idx="3">
-            <a:schemeClr val="accent1"/>
-          </a:fillRef>
-          <a:effectRef idx="2">
-            <a:schemeClr val="accent1"/>
-          </a:effectRef>
-          <a:fontRef idx="minor">
-            <a:schemeClr val="lt1"/>
-          </a:fontRef>
-        </p:style>
-        <p:txBody>
-          <a:bodyPr rtlCol="0" anchor="ctr" wrap="square"/>
-          <a:lstStyle/>
-          <a:p>
-            <a:pPr algn="ctr"/>
-          </a:p>
-        </p:txBody>
-      </p:sp>
-      <p:sp>
-        <p:nvSpPr>
-          <p:cNvPr id="17" name="Rounded Rectangle 16"/>
-          <p:cNvSpPr/>
-          <p:nvPr/>
-        </p:nvSpPr>
-        <p:spPr>
-          <a:xfrm>
-            <a:off x="3358819" y="2843784"/>
-            <a:ext cx="2645587" cy="1249680"/>
-          </a:xfrm>
-          <a:prstGeom prst="roundRect">
-            <a:avLst>
-              <a:gd name="adj" fmla="val 5000"/>
-            </a:avLst>
-          </a:prstGeom>
-          <a:solidFill>
-            <a:srgbClr val="FFFFFF"/>
-          </a:solidFill>
-          <a:ln w="9525">
-            <a:solidFill>
-              <a:srgbClr val="E4E1F1"/>
-            </a:solidFill>
-          </a:ln>
-          <a:effectLst>
-            <a:outerShdw blurRad="76200" dist="19050" dir="5400000" algn="bl" rotWithShape="0">
-              <a:srgbClr val="1A0F5C">
-                <a:alpha val="12000"/>
-              </a:srgbClr>
-            </a:outerShdw>
-          </a:effectLst>
-        </p:spPr>
-        <p:style>
-          <a:lnRef idx="1">
-            <a:schemeClr val="accent1"/>
-          </a:lnRef>
-          <a:fillRef idx="3">
-            <a:schemeClr val="accent1"/>
-          </a:fillRef>
-          <a:effectRef idx="2">
-            <a:schemeClr val="accent1"/>
-          </a:effectRef>
-          <a:fontRef idx="minor">
-            <a:schemeClr val="lt1"/>
-          </a:fontRef>
-        </p:style>
-        <p:txBody>
-          <a:bodyPr rtlCol="0" anchor="ctr" wrap="square"/>
-          <a:lstStyle/>
-          <a:p>
-            <a:pPr algn="ctr"/>
-          </a:p>
-        </p:txBody>
-      </p:sp>
-      <p:sp>
-        <p:nvSpPr>
-          <p:cNvPr id="18" name="TextBox 17"/>
-          <p:cNvSpPr txBox="1"/>
-          <p:nvPr/>
-        </p:nvSpPr>
-        <p:spPr>
-          <a:xfrm>
-            <a:off x="3523411" y="2990088"/>
-            <a:ext cx="2316403" cy="251205"/>
-          </a:xfrm>
-          <a:prstGeom prst="rect">
-            <a:avLst/>
-          </a:prstGeom>
-          <a:noFill/>
-        </p:spPr>
-        <p:txBody>
-          <a:bodyPr wrap="square" anchor="t" lIns="0" rIns="0" tIns="0" bIns="0">
-            <a:spAutoFit/>
-          </a:bodyPr>
-          <a:lstStyle/>
-          <a:p>
-            <a:pPr algn="l"/>
-            <a:r>
-              <a:rPr sz="1300" b="1" i="0">
-                <a:solidFill>
-                  <a:srgbClr val="1A0F5C"/>
-                </a:solidFill>
-                <a:latin typeface="Calibri"/>
-              </a:rPr>
-              <a:t>The real gap</a:t>
-            </a:r>
-          </a:p>
-        </p:txBody>
-      </p:sp>
-      <p:sp>
-        <p:nvSpPr>
-          <p:cNvPr id="19" name="TextBox 18"/>
-          <p:cNvSpPr txBox="1"/>
-          <p:nvPr/>
-        </p:nvSpPr>
-        <p:spPr>
-          <a:xfrm>
-            <a:off x="3523411" y="3277870"/>
-            <a:ext cx="2316403" cy="366776"/>
-          </a:xfrm>
-          <a:prstGeom prst="rect">
-            <a:avLst/>
-          </a:prstGeom>
-          <a:noFill/>
-        </p:spPr>
-        <p:txBody>
-          <a:bodyPr wrap="square" anchor="t" lIns="0" rIns="0" tIns="0" bIns="0">
-            <a:spAutoFit/>
-          </a:bodyPr>
-          <a:lstStyle/>
-          <a:p>
-            <a:pPr algn="l"/>
-            <a:r>
-              <a:rPr sz="1000" b="0" i="0">
-                <a:solidFill>
-                  <a:srgbClr val="6B6690"/>
-                </a:solidFill>
-                <a:latin typeface="Calibri"/>
-              </a:rPr>
-              <a:t>Q1 mean less Q2 mean, printed in rupees before any shuffle runs.</a:t>
-            </a:r>
-          </a:p>
-        </p:txBody>
-      </p:sp>
-      <p:sp>
-        <p:nvSpPr>
-          <p:cNvPr id="20" name="TextBox 19"/>
-          <p:cNvSpPr txBox="1"/>
-          <p:nvPr/>
-        </p:nvSpPr>
-        <p:spPr>
-          <a:xfrm>
-            <a:off x="6187287" y="1956816"/>
-            <a:ext cx="2645587" cy="168656"/>
-          </a:xfrm>
-          <a:prstGeom prst="rect">
-            <a:avLst/>
-          </a:prstGeom>
-          <a:noFill/>
-        </p:spPr>
-        <p:txBody>
-          <a:bodyPr wrap="square" anchor="t" lIns="0" rIns="0" tIns="0" bIns="0">
-            <a:spAutoFit/>
-          </a:bodyPr>
-          <a:lstStyle/>
-          <a:p>
-            <a:pPr algn="ctr"/>
-            <a:r>
-              <a:rPr sz="800" b="1" i="0" spc="250">
-                <a:solidFill>
-                  <a:srgbClr val="5B3FD6"/>
-                </a:solidFill>
-                <a:latin typeface="Calibri"/>
-              </a:rPr>
-              <a:t>STEP 3</a:t>
-            </a:r>
-          </a:p>
-        </p:txBody>
-      </p:sp>
-      <p:sp>
-        <p:nvSpPr>
-          <p:cNvPr id="21" name="Oval 20"/>
-          <p:cNvSpPr/>
-          <p:nvPr/>
-        </p:nvSpPr>
-        <p:spPr>
-          <a:xfrm>
-            <a:off x="7409497" y="2432304"/>
-            <a:ext cx="201168" cy="201168"/>
-          </a:xfrm>
-          <a:prstGeom prst="ellipse">
-            <a:avLst/>
-          </a:prstGeom>
-          <a:solidFill>
-            <a:srgbClr val="5B3FD6"/>
-          </a:solidFill>
-          <a:ln>
-            <a:noFill/>
-          </a:ln>
-          <a:effectLst/>
-        </p:spPr>
-        <p:style>
-          <a:lnRef idx="1">
-            <a:schemeClr val="accent1"/>
-          </a:lnRef>
-          <a:fillRef idx="3">
-            <a:schemeClr val="accent1"/>
-          </a:fillRef>
-          <a:effectRef idx="2">
-            <a:schemeClr val="accent1"/>
-          </a:effectRef>
-          <a:fontRef idx="minor">
-            <a:schemeClr val="lt1"/>
-          </a:fontRef>
-        </p:style>
-        <p:txBody>
-          <a:bodyPr rtlCol="0" anchor="ctr" wrap="square"/>
-          <a:lstStyle/>
-          <a:p>
-            <a:pPr algn="ctr"/>
-          </a:p>
-        </p:txBody>
-      </p:sp>
-      <p:sp>
-        <p:nvSpPr>
-          <p:cNvPr id="22" name="Rounded Rectangle 21"/>
-          <p:cNvSpPr/>
-          <p:nvPr/>
-        </p:nvSpPr>
-        <p:spPr>
-          <a:xfrm>
-            <a:off x="6187287" y="2843784"/>
-            <a:ext cx="2645587" cy="1249680"/>
-          </a:xfrm>
-          <a:prstGeom prst="roundRect">
-            <a:avLst>
-              <a:gd name="adj" fmla="val 5000"/>
-            </a:avLst>
-          </a:prstGeom>
-          <a:solidFill>
-            <a:srgbClr val="FFFFFF"/>
-          </a:solidFill>
-          <a:ln w="9525">
-            <a:solidFill>
-              <a:srgbClr val="E4E1F1"/>
-            </a:solidFill>
-          </a:ln>
-          <a:effectLst>
-            <a:outerShdw blurRad="76200" dist="19050" dir="5400000" algn="bl" rotWithShape="0">
-              <a:srgbClr val="1A0F5C">
-                <a:alpha val="12000"/>
-              </a:srgbClr>
-            </a:outerShdw>
-          </a:effectLst>
-        </p:spPr>
-        <p:style>
-          <a:lnRef idx="1">
-            <a:schemeClr val="accent1"/>
-          </a:lnRef>
-          <a:fillRef idx="3">
-            <a:schemeClr val="accent1"/>
-          </a:fillRef>
-          <a:effectRef idx="2">
-            <a:schemeClr val="accent1"/>
-          </a:effectRef>
-          <a:fontRef idx="minor">
-            <a:schemeClr val="lt1"/>
-          </a:fontRef>
-        </p:style>
-        <p:txBody>
-          <a:bodyPr rtlCol="0" anchor="ctr" wrap="square"/>
-          <a:lstStyle/>
-          <a:p>
-            <a:pPr algn="ctr"/>
-          </a:p>
-        </p:txBody>
-      </p:sp>
-      <p:sp>
-        <p:nvSpPr>
-          <p:cNvPr id="23" name="TextBox 22"/>
-          <p:cNvSpPr txBox="1"/>
-          <p:nvPr/>
-        </p:nvSpPr>
-        <p:spPr>
-          <a:xfrm>
-            <a:off x="6351879" y="2990088"/>
-            <a:ext cx="2316403" cy="251205"/>
-          </a:xfrm>
-          <a:prstGeom prst="rect">
-            <a:avLst/>
-          </a:prstGeom>
-          <a:noFill/>
-        </p:spPr>
-        <p:txBody>
-          <a:bodyPr wrap="square" anchor="t" lIns="0" rIns="0" tIns="0" bIns="0">
-            <a:spAutoFit/>
-          </a:bodyPr>
-          <a:lstStyle/>
-          <a:p>
-            <a:pPr algn="l"/>
-            <a:r>
-              <a:rPr sz="1300" b="1" i="0">
-                <a:solidFill>
-                  <a:srgbClr val="1A0F5C"/>
-                </a:solidFill>
-                <a:latin typeface="Calibri"/>
-              </a:rPr>
-              <a:t>The shuffles</a:t>
-            </a:r>
-          </a:p>
-        </p:txBody>
-      </p:sp>
-      <p:sp>
-        <p:nvSpPr>
-          <p:cNvPr id="24" name="TextBox 23"/>
-          <p:cNvSpPr txBox="1"/>
-          <p:nvPr/>
-        </p:nvSpPr>
-        <p:spPr>
-          <a:xfrm>
-            <a:off x="6351879" y="3277870"/>
-            <a:ext cx="2316403" cy="366776"/>
-          </a:xfrm>
-          <a:prstGeom prst="rect">
-            <a:avLst/>
-          </a:prstGeom>
-          <a:noFill/>
-        </p:spPr>
-        <p:txBody>
-          <a:bodyPr wrap="square" anchor="t" lIns="0" rIns="0" tIns="0" bIns="0">
-            <a:spAutoFit/>
-          </a:bodyPr>
-          <a:lstStyle/>
-          <a:p>
-            <a:pPr algn="l"/>
-            <a:r>
-              <a:rPr sz="1000" b="0" i="0">
-                <a:solidFill>
-                  <a:srgbClr val="6B6690"/>
-                </a:solidFill>
-                <a:latin typeface="Calibri"/>
-              </a:rPr>
-              <a:t>5,000, seed 2026, and the share at least as large as the real gap.</a:t>
-            </a:r>
-          </a:p>
-        </p:txBody>
-      </p:sp>
-      <p:sp>
-        <p:nvSpPr>
-          <p:cNvPr id="25" name="TextBox 24"/>
-          <p:cNvSpPr txBox="1"/>
-          <p:nvPr/>
-        </p:nvSpPr>
-        <p:spPr>
-          <a:xfrm>
-            <a:off x="9015755" y="1956816"/>
-            <a:ext cx="2645587" cy="168656"/>
-          </a:xfrm>
-          <a:prstGeom prst="rect">
-            <a:avLst/>
-          </a:prstGeom>
-          <a:noFill/>
-        </p:spPr>
-        <p:txBody>
-          <a:bodyPr wrap="square" anchor="t" lIns="0" rIns="0" tIns="0" bIns="0">
-            <a:spAutoFit/>
-          </a:bodyPr>
-          <a:lstStyle/>
-          <a:p>
-            <a:pPr algn="ctr"/>
-            <a:r>
-              <a:rPr sz="800" b="1" i="0" spc="250">
-                <a:solidFill>
-                  <a:srgbClr val="5B3FD6"/>
-                </a:solidFill>
-                <a:latin typeface="Calibri"/>
-              </a:rPr>
-              <a:t>STEP 4</a:t>
-            </a:r>
-          </a:p>
-        </p:txBody>
-      </p:sp>
-      <p:sp>
-        <p:nvSpPr>
-          <p:cNvPr id="26" name="Oval 25"/>
-          <p:cNvSpPr/>
-          <p:nvPr/>
-        </p:nvSpPr>
-        <p:spPr>
-          <a:xfrm>
-            <a:off x="10237965" y="2432304"/>
-            <a:ext cx="201168" cy="201168"/>
-          </a:xfrm>
-          <a:prstGeom prst="ellipse">
-            <a:avLst/>
-          </a:prstGeom>
-          <a:solidFill>
-            <a:srgbClr val="D9A7FF"/>
-          </a:solidFill>
-          <a:ln>
-            <a:noFill/>
-          </a:ln>
-          <a:effectLst/>
-        </p:spPr>
-        <p:style>
-          <a:lnRef idx="1">
-            <a:schemeClr val="accent1"/>
-          </a:lnRef>
-          <a:fillRef idx="3">
-            <a:schemeClr val="accent1"/>
-          </a:fillRef>
-          <a:effectRef idx="2">
-            <a:schemeClr val="accent1"/>
-          </a:effectRef>
-          <a:fontRef idx="minor">
-            <a:schemeClr val="lt1"/>
-          </a:fontRef>
-        </p:style>
-        <p:txBody>
-          <a:bodyPr rtlCol="0" anchor="ctr" wrap="square"/>
-          <a:lstStyle/>
-          <a:p>
-            <a:pPr algn="ctr"/>
-          </a:p>
-        </p:txBody>
-      </p:sp>
-      <p:sp>
-        <p:nvSpPr>
-          <p:cNvPr id="27" name="Rounded Rectangle 26"/>
-          <p:cNvSpPr/>
-          <p:nvPr/>
-        </p:nvSpPr>
-        <p:spPr>
-          <a:xfrm>
-            <a:off x="9015755" y="2843784"/>
-            <a:ext cx="2645587" cy="1249680"/>
-          </a:xfrm>
-          <a:prstGeom prst="roundRect">
-            <a:avLst>
-              <a:gd name="adj" fmla="val 5000"/>
-            </a:avLst>
-          </a:prstGeom>
-          <a:gradFill rotWithShape="1">
-            <a:gsLst>
-              <a:gs pos="0">
-                <a:srgbClr val="2C1A86"/>
-              </a:gs>
-              <a:gs pos="100000">
-                <a:srgbClr val="1A0F5C"/>
-              </a:gs>
-            </a:gsLst>
-            <a:lin scaled="0" ang="16200000"/>
-          </a:gradFill>
-          <a:ln>
-            <a:noFill/>
-          </a:ln>
-          <a:effectLst>
-            <a:outerShdw blurRad="76200" dist="19050" dir="5400000" algn="bl" rotWithShape="0">
-              <a:srgbClr val="1A0F5C">
-                <a:alpha val="12000"/>
-              </a:srgbClr>
-            </a:outerShdw>
-          </a:effectLst>
-        </p:spPr>
-        <p:style>
-          <a:lnRef idx="1">
-            <a:schemeClr val="accent1"/>
-          </a:lnRef>
-          <a:fillRef idx="3">
-            <a:schemeClr val="accent1"/>
-          </a:fillRef>
-          <a:effectRef idx="2">
-            <a:schemeClr val="accent1"/>
-          </a:effectRef>
-          <a:fontRef idx="minor">
-            <a:schemeClr val="lt1"/>
-          </a:fontRef>
-        </p:style>
-        <p:txBody>
-          <a:bodyPr rtlCol="0" anchor="ctr" wrap="square"/>
-          <a:lstStyle/>
-          <a:p>
-            <a:pPr algn="ctr"/>
-          </a:p>
-        </p:txBody>
-      </p:sp>
-      <p:sp>
-        <p:nvSpPr>
-          <p:cNvPr id="28" name="TextBox 27"/>
-          <p:cNvSpPr txBox="1"/>
-          <p:nvPr/>
-        </p:nvSpPr>
-        <p:spPr>
-          <a:xfrm>
-            <a:off x="9180347" y="2990088"/>
-            <a:ext cx="2316403" cy="251205"/>
-          </a:xfrm>
-          <a:prstGeom prst="rect">
-            <a:avLst/>
-          </a:prstGeom>
-          <a:noFill/>
-        </p:spPr>
-        <p:txBody>
-          <a:bodyPr wrap="square" anchor="t" lIns="0" rIns="0" tIns="0" bIns="0">
-            <a:spAutoFit/>
-          </a:bodyPr>
-          <a:lstStyle/>
-          <a:p>
-            <a:pPr algn="l"/>
-            <a:r>
-              <a:rPr sz="1300" b="1" i="0">
-                <a:solidFill>
-                  <a:srgbClr val="FFFFFF"/>
-                </a:solidFill>
-                <a:latin typeface="Calibri"/>
-              </a:rPr>
-              <a:t>The sentence</a:t>
-            </a:r>
-          </a:p>
-        </p:txBody>
-      </p:sp>
-      <p:sp>
-        <p:nvSpPr>
-          <p:cNvPr id="29" name="TextBox 28"/>
-          <p:cNvSpPr txBox="1"/>
-          <p:nvPr/>
-        </p:nvSpPr>
-        <p:spPr>
-          <a:xfrm>
-            <a:off x="9180347" y="3277870"/>
-            <a:ext cx="2316403" cy="366776"/>
-          </a:xfrm>
-          <a:prstGeom prst="rect">
-            <a:avLst/>
-          </a:prstGeom>
-          <a:noFill/>
-        </p:spPr>
-        <p:txBody>
-          <a:bodyPr wrap="square" anchor="t" lIns="0" rIns="0" tIns="0" bIns="0">
-            <a:spAutoFit/>
-          </a:bodyPr>
-          <a:lstStyle/>
-          <a:p>
-            <a:pPr algn="l"/>
-            <a:r>
-              <a:rPr sz="1000" b="0" i="0">
-                <a:solidFill>
-                  <a:srgbClr val="CFC9EE"/>
-                </a:solidFill>
-                <a:latin typeface="Calibri"/>
-              </a:rPr>
-              <a:t>One line in the rewritten form, read aloud to your partner.</a:t>
-            </a:r>
-          </a:p>
-        </p:txBody>
-      </p:sp>
-      <p:sp>
-        <p:nvSpPr>
-          <p:cNvPr id="30" name="Oval 29"/>
-          <p:cNvSpPr/>
-          <p:nvPr/>
-        </p:nvSpPr>
-        <p:spPr>
-          <a:xfrm>
-            <a:off x="530352" y="6492240"/>
-            <a:ext cx="64008" cy="64008"/>
-          </a:xfrm>
-          <a:prstGeom prst="ellipse">
-            <a:avLst/>
-          </a:prstGeom>
-          <a:solidFill>
-            <a:srgbClr val="CFC9EE"/>
-          </a:solidFill>
-          <a:ln>
-            <a:noFill/>
-          </a:ln>
-          <a:effectLst/>
-        </p:spPr>
-        <p:style>
-          <a:lnRef idx="1">
-            <a:schemeClr val="accent1"/>
-          </a:lnRef>
-          <a:fillRef idx="3">
-            <a:schemeClr val="accent1"/>
-          </a:fillRef>
-          <a:effectRef idx="2">
-            <a:schemeClr val="accent1"/>
-          </a:effectRef>
-          <a:fontRef idx="minor">
-            <a:schemeClr val="lt1"/>
-          </a:fontRef>
-        </p:style>
-        <p:txBody>
-          <a:bodyPr rtlCol="0" anchor="ctr" wrap="square"/>
-          <a:lstStyle/>
-          <a:p>
-            <a:pPr algn="ctr"/>
-          </a:p>
-        </p:txBody>
-      </p:sp>
-      <p:sp>
-        <p:nvSpPr>
-          <p:cNvPr id="31" name="TextBox 30"/>
-          <p:cNvSpPr txBox="1"/>
-          <p:nvPr/>
-        </p:nvSpPr>
-        <p:spPr>
-          <a:xfrm>
-            <a:off x="640080" y="6437376"/>
-            <a:ext cx="596360" cy="152146"/>
-          </a:xfrm>
-          <a:prstGeom prst="rect">
-            <a:avLst/>
-          </a:prstGeom>
-          <a:noFill/>
-        </p:spPr>
-        <p:txBody>
-          <a:bodyPr wrap="square" anchor="t" lIns="0" rIns="0" tIns="0" bIns="0">
-            <a:spAutoFit/>
-          </a:bodyPr>
-          <a:lstStyle/>
-          <a:p>
-            <a:pPr algn="l"/>
-            <a:r>
-              <a:rPr sz="700" b="0" i="0">
-                <a:solidFill>
-                  <a:srgbClr val="6B6690"/>
-                </a:solidFill>
-                <a:latin typeface="Calibri"/>
-              </a:rPr>
-              <a:t>The ask</a:t>
-            </a:r>
-          </a:p>
-        </p:txBody>
-      </p:sp>
-      <p:sp>
-        <p:nvSpPr>
-          <p:cNvPr id="32" name="Oval 31"/>
-          <p:cNvSpPr/>
-          <p:nvPr/>
-        </p:nvSpPr>
-        <p:spPr>
-          <a:xfrm>
-            <a:off x="1327880" y="6492240"/>
-            <a:ext cx="64008" cy="64008"/>
-          </a:xfrm>
-          <a:prstGeom prst="ellipse">
-            <a:avLst/>
-          </a:prstGeom>
-          <a:solidFill>
-            <a:srgbClr val="5B3FD6"/>
-          </a:solidFill>
-          <a:ln>
-            <a:noFill/>
-          </a:ln>
-          <a:effectLst/>
-        </p:spPr>
-        <p:style>
-          <a:lnRef idx="1">
-            <a:schemeClr val="accent1"/>
-          </a:lnRef>
-          <a:fillRef idx="3">
-            <a:schemeClr val="accent1"/>
-          </a:fillRef>
-          <a:effectRef idx="2">
-            <a:schemeClr val="accent1"/>
-          </a:effectRef>
-          <a:fontRef idx="minor">
-            <a:schemeClr val="lt1"/>
-          </a:fontRef>
-        </p:style>
-        <p:txBody>
-          <a:bodyPr rtlCol="0" anchor="ctr" wrap="square"/>
-          <a:lstStyle/>
-          <a:p>
-            <a:pPr algn="ctr"/>
-          </a:p>
-        </p:txBody>
-      </p:sp>
-      <p:sp>
-        <p:nvSpPr>
-          <p:cNvPr id="33" name="TextBox 32"/>
-          <p:cNvSpPr txBox="1"/>
-          <p:nvPr/>
-        </p:nvSpPr>
-        <p:spPr>
-          <a:xfrm>
-            <a:off x="1437608" y="6437376"/>
-            <a:ext cx="1562480" cy="152146"/>
-          </a:xfrm>
-          <a:prstGeom prst="rect">
-            <a:avLst/>
-          </a:prstGeom>
-          <a:noFill/>
-        </p:spPr>
-        <p:txBody>
-          <a:bodyPr wrap="square" anchor="t" lIns="0" rIns="0" tIns="0" bIns="0">
-            <a:spAutoFit/>
-          </a:bodyPr>
-          <a:lstStyle/>
-          <a:p>
-            <a:pPr algn="l"/>
-            <a:r>
-              <a:rPr sz="700" b="1" i="0">
-                <a:solidFill>
-                  <a:srgbClr val="5B3FD6"/>
-                </a:solidFill>
-                <a:latin typeface="Calibri"/>
-              </a:rPr>
-              <a:t>Round 1. Real, or the wobble</a:t>
-            </a:r>
-          </a:p>
-        </p:txBody>
-      </p:sp>
-      <p:sp>
-        <p:nvSpPr>
-          <p:cNvPr id="34" name="Oval 33"/>
-          <p:cNvSpPr/>
-          <p:nvPr/>
-        </p:nvSpPr>
-        <p:spPr>
-          <a:xfrm>
-            <a:off x="3091529" y="6492240"/>
-            <a:ext cx="64008" cy="64008"/>
-          </a:xfrm>
-          <a:prstGeom prst="ellipse">
-            <a:avLst/>
-          </a:prstGeom>
-          <a:solidFill>
-            <a:srgbClr val="CFC9EE"/>
-          </a:solidFill>
-          <a:ln>
-            <a:noFill/>
-          </a:ln>
-          <a:effectLst/>
-        </p:spPr>
-        <p:style>
-          <a:lnRef idx="1">
-            <a:schemeClr val="accent1"/>
-          </a:lnRef>
-          <a:fillRef idx="3">
-            <a:schemeClr val="accent1"/>
-          </a:fillRef>
-          <a:effectRef idx="2">
-            <a:schemeClr val="accent1"/>
-          </a:effectRef>
-          <a:fontRef idx="minor">
-            <a:schemeClr val="lt1"/>
-          </a:fontRef>
-        </p:style>
-        <p:txBody>
-          <a:bodyPr rtlCol="0" anchor="ctr" wrap="square"/>
-          <a:lstStyle/>
-          <a:p>
-            <a:pPr algn="ctr"/>
-          </a:p>
-        </p:txBody>
-      </p:sp>
-      <p:sp>
-        <p:nvSpPr>
-          <p:cNvPr id="35" name="TextBox 34"/>
-          <p:cNvSpPr txBox="1"/>
-          <p:nvPr/>
-        </p:nvSpPr>
-        <p:spPr>
-          <a:xfrm>
-            <a:off x="3201257" y="6437376"/>
-            <a:ext cx="1378457" cy="152146"/>
-          </a:xfrm>
-          <a:prstGeom prst="rect">
-            <a:avLst/>
-          </a:prstGeom>
-          <a:noFill/>
-        </p:spPr>
-        <p:txBody>
-          <a:bodyPr wrap="square" anchor="t" lIns="0" rIns="0" tIns="0" bIns="0">
-            <a:spAutoFit/>
-          </a:bodyPr>
-          <a:lstStyle/>
-          <a:p>
-            <a:pPr algn="l"/>
-            <a:r>
-              <a:rPr sz="700" b="0" i="0">
-                <a:solidFill>
-                  <a:srgbClr val="6B6690"/>
-                </a:solidFill>
-                <a:latin typeface="Calibri"/>
-              </a:rPr>
-              <a:t>Round 2. Worth acting on</a:t>
-            </a:r>
-          </a:p>
-        </p:txBody>
-      </p:sp>
-      <p:sp>
-        <p:nvSpPr>
-          <p:cNvPr id="36" name="Oval 35"/>
-          <p:cNvSpPr/>
-          <p:nvPr/>
-        </p:nvSpPr>
-        <p:spPr>
-          <a:xfrm>
-            <a:off x="4671155" y="6492240"/>
-            <a:ext cx="64008" cy="64008"/>
-          </a:xfrm>
-          <a:prstGeom prst="ellipse">
-            <a:avLst/>
-          </a:prstGeom>
-          <a:solidFill>
-            <a:srgbClr val="CFC9EE"/>
-          </a:solidFill>
-          <a:ln>
-            <a:noFill/>
-          </a:ln>
-          <a:effectLst/>
-        </p:spPr>
-        <p:style>
-          <a:lnRef idx="1">
-            <a:schemeClr val="accent1"/>
-          </a:lnRef>
-          <a:fillRef idx="3">
-            <a:schemeClr val="accent1"/>
-          </a:fillRef>
-          <a:effectRef idx="2">
-            <a:schemeClr val="accent1"/>
-          </a:effectRef>
-          <a:fontRef idx="minor">
-            <a:schemeClr val="lt1"/>
-          </a:fontRef>
-        </p:style>
-        <p:txBody>
-          <a:bodyPr rtlCol="0" anchor="ctr" wrap="square"/>
-          <a:lstStyle/>
-          <a:p>
-            <a:pPr algn="ctr"/>
-          </a:p>
-        </p:txBody>
-      </p:sp>
-      <p:sp>
-        <p:nvSpPr>
-          <p:cNvPr id="37" name="TextBox 36"/>
-          <p:cNvSpPr txBox="1"/>
-          <p:nvPr/>
-        </p:nvSpPr>
-        <p:spPr>
-          <a:xfrm>
-            <a:off x="4780883" y="6437376"/>
-            <a:ext cx="1930527" cy="152146"/>
-          </a:xfrm>
-          <a:prstGeom prst="rect">
-            <a:avLst/>
-          </a:prstGeom>
-          <a:noFill/>
-        </p:spPr>
-        <p:txBody>
-          <a:bodyPr wrap="square" anchor="t" lIns="0" rIns="0" tIns="0" bIns="0">
-            <a:spAutoFit/>
-          </a:bodyPr>
-          <a:lstStyle/>
-          <a:p>
-            <a:pPr algn="l"/>
-            <a:r>
-              <a:rPr sz="700" b="0" i="0">
-                <a:solidFill>
-                  <a:srgbClr val="6B6690"/>
-                </a:solidFill>
-                <a:latin typeface="Calibri"/>
-              </a:rPr>
-              <a:t>Round 3. The count behind 40 percent</a:t>
-            </a:r>
-          </a:p>
-        </p:txBody>
-      </p:sp>
-      <p:sp>
-        <p:nvSpPr>
-          <p:cNvPr id="38" name="TextBox 37"/>
-          <p:cNvSpPr txBox="1"/>
-          <p:nvPr/>
-        </p:nvSpPr>
-        <p:spPr>
-          <a:xfrm>
-            <a:off x="10198303" y="6437376"/>
-            <a:ext cx="1463040" cy="160401"/>
-          </a:xfrm>
-          <a:prstGeom prst="rect">
-            <a:avLst/>
-          </a:prstGeom>
-          <a:noFill/>
-        </p:spPr>
-        <p:txBody>
-          <a:bodyPr wrap="square" anchor="t" lIns="0" rIns="0" tIns="0" bIns="0">
-            <a:spAutoFit/>
-          </a:bodyPr>
-          <a:lstStyle/>
-          <a:p>
-            <a:pPr algn="r"/>
-            <a:r>
-              <a:rPr sz="750" b="0" i="0">
-                <a:solidFill>
-                  <a:srgbClr val="6B6690"/>
-                </a:solidFill>
-                <a:latin typeface="Calibri"/>
-              </a:rPr>
               <a:t>S16  ·  19 / 44</a:t>
             </a:r>
           </a:p>
@@ -17606,7 +17621,7 @@
                 </a:solidFill>
                 <a:latin typeface="Calibri"/>
               </a:rPr>
-              <a:t>Week 1 Day 4: real, worth it, and caused?</a:t>
+              <a:t>Week 1, Day 4. Real, or the usual wobble?</a:t>
             </a:r>
           </a:p>
         </p:txBody>
@@ -19146,7 +19161,7 @@
                 </a:solidFill>
                 <a:latin typeface="Calibri"/>
               </a:rPr>
-              <a:t>Week 1 Day 4: real, worth it, and caused?</a:t>
+              <a:t>Week 1, Day 4. Real, or the usual wobble?</a:t>
             </a:r>
           </a:p>
         </p:txBody>
@@ -21682,14 +21697,14 @@
                 </a:solidFill>
                 <a:latin typeface="Calibri"/>
               </a:rPr>
-              <a:t>The draft ranks Retail-Plus first because its p-value is the smallest on the page.</a:t>
+              <a:t>The draft ranks Retail-Plus first because the room's own p-value is the smallest on the page.</a:t>
             </a:r>
           </a:p>
         </p:txBody>
       </p:sp>
       <p:pic>
         <p:nvPicPr>
-          <p:cNvPr id="9" name="mermaid diagram" descr="c1625a15d5586065.png"/>
+          <p:cNvPr id="9" name="mermaid diagram" descr="b50dc4998ea915b9.png"/>
           <p:cNvPicPr>
             <a:picLocks noChangeAspect="1"/>
           </p:cNvPicPr>
@@ -24791,7 +24806,7 @@
       </p:sp>
       <p:pic>
         <p:nvPicPr>
-          <p:cNvPr id="9" name="mermaid diagram" descr="1d9c244cae2f94d3.png"/>
+          <p:cNvPr id="9" name="mermaid diagram" descr="7622c699aa10bf66.png"/>
           <p:cNvPicPr>
             <a:picLocks noChangeAspect="1"/>
           </p:cNvPicPr>
@@ -24842,7 +24857,7 @@
                 </a:solidFill>
                 <a:latin typeface="Calibri"/>
               </a:rPr>
-              <a:t>The consumer bars are too small to see at this scale, which is itself the finding: size every consumer gap against a quarter that Business dominates.</a:t>
+              <a:t>Business delivered Rs 1,27,64,460 in the same quarter, about 268 times Retail-Plus, so on this axis its bar would stand 268 times as tall. Size every consumer gap against a quarter that Business dominates.</a:t>
             </a:r>
           </a:p>
         </p:txBody>
@@ -30990,7 +31005,7 @@
                 </a:solidFill>
                 <a:latin typeface="Calibri"/>
               </a:rPr>
-              <a:t>Week 1 Day 4: real, worth it, and caused?</a:t>
+              <a:t>Week 1, Day 4. Real, or the usual wobble?</a:t>
             </a:r>
           </a:p>
         </p:txBody>
@@ -45822,7 +45837,7 @@
                 </a:solidFill>
                 <a:latin typeface="Calibri"/>
               </a:rPr>
-              <a:t>Week 1 Day 4: real, worth it, and caused?</a:t>
+              <a:t>Week 1, Day 4. Real, or the usual wobble?</a:t>
             </a:r>
           </a:p>
         </p:txBody>

</xml_diff>